<commit_message>
material clase 8 actualizado
</commit_message>
<xml_diff>
--- a/clase_6/teoria/Clase_6.pptx
+++ b/clase_6/teoria/Clase_6.pptx
@@ -320,2123 +320,44 @@
 </p:presentation>
 </file>
 
-<file path=ppt/revisionInfo.xml><?xml version="1.0" encoding="utf-8"?>
-<p1510:revInfo xmlns:a="http://schemas.openxmlformats.org/drawingml/2006/main" xmlns:r="http://schemas.openxmlformats.org/officeDocument/2006/relationships" xmlns:p1510="http://schemas.microsoft.com/office/powerpoint/2015/10/main">
-  <p1510:revLst>
-    <p1510:client id="{2319D230-8B6D-4D68-A7A6-9DA4EF63D37F}" v="32" dt="2025-11-26T00:59:33.472"/>
-  </p1510:revLst>
-</p1510:revInfo>
-</file>
-
 <file path=ppt/changesInfos/changesInfo1.xml><?xml version="1.0" encoding="utf-8"?>
 <pc:chgInfo xmlns:a="http://schemas.openxmlformats.org/drawingml/2006/main" xmlns:r="http://schemas.openxmlformats.org/officeDocument/2006/relationships" xmlns:ac="http://schemas.microsoft.com/office/drawing/2013/main/command" xmlns:pc="http://schemas.microsoft.com/office/powerpoint/2013/main/command">
   <pc:docChgLst>
-    <pc:chgData name="Marcos Maillot" userId="fa14b39d-e966-4ebb-a436-4f96f84b9577" providerId="ADAL" clId="{2D40D906-DE93-44E5-B192-09259B1B360B}"/>
-    <pc:docChg chg="custSel addSld delSld modSld">
-      <pc:chgData name="Marcos Maillot" userId="fa14b39d-e966-4ebb-a436-4f96f84b9577" providerId="ADAL" clId="{2D40D906-DE93-44E5-B192-09259B1B360B}" dt="2025-11-26T00:59:33.472" v="217"/>
-      <pc:docMkLst>
-        <pc:docMk/>
-      </pc:docMkLst>
-      <pc:sldChg chg="addSp modSp mod">
-        <pc:chgData name="Marcos Maillot" userId="fa14b39d-e966-4ebb-a436-4f96f84b9577" providerId="ADAL" clId="{2D40D906-DE93-44E5-B192-09259B1B360B}" dt="2025-11-25T22:34:28.050" v="42"/>
-        <pc:sldMkLst>
-          <pc:docMk/>
-          <pc:sldMk cId="0" sldId="266"/>
-        </pc:sldMkLst>
-        <pc:grpChg chg="mod">
-          <ac:chgData name="Marcos Maillot" userId="fa14b39d-e966-4ebb-a436-4f96f84b9577" providerId="ADAL" clId="{2D40D906-DE93-44E5-B192-09259B1B360B}" dt="2025-11-25T22:33:52.277" v="14"/>
-          <ac:grpSpMkLst>
-            <pc:docMk/>
-            <pc:sldMk cId="0" sldId="266"/>
-            <ac:grpSpMk id="5" creationId="{F7F557D2-3677-8A64-004D-A683CE1C0C0F}"/>
-          </ac:grpSpMkLst>
-        </pc:grpChg>
-        <pc:grpChg chg="mod">
-          <ac:chgData name="Marcos Maillot" userId="fa14b39d-e966-4ebb-a436-4f96f84b9577" providerId="ADAL" clId="{2D40D906-DE93-44E5-B192-09259B1B360B}" dt="2025-11-25T22:33:55.490" v="18"/>
-          <ac:grpSpMkLst>
-            <pc:docMk/>
-            <pc:sldMk cId="0" sldId="266"/>
-            <ac:grpSpMk id="9" creationId="{AF0735D1-3B23-1F69-8AF9-E81615CF3E51}"/>
-          </ac:grpSpMkLst>
-        </pc:grpChg>
-        <pc:grpChg chg="mod">
-          <ac:chgData name="Marcos Maillot" userId="fa14b39d-e966-4ebb-a436-4f96f84b9577" providerId="ADAL" clId="{2D40D906-DE93-44E5-B192-09259B1B360B}" dt="2025-11-25T22:34:05.593" v="26"/>
-          <ac:grpSpMkLst>
-            <pc:docMk/>
-            <pc:sldMk cId="0" sldId="266"/>
-            <ac:grpSpMk id="17" creationId="{51699128-F7D1-1269-291F-4B2CD6755E9B}"/>
-          </ac:grpSpMkLst>
-        </pc:grpChg>
-        <pc:grpChg chg="mod">
-          <ac:chgData name="Marcos Maillot" userId="fa14b39d-e966-4ebb-a436-4f96f84b9577" providerId="ADAL" clId="{2D40D906-DE93-44E5-B192-09259B1B360B}" dt="2025-11-25T22:34:18.445" v="34"/>
-          <ac:grpSpMkLst>
-            <pc:docMk/>
-            <pc:sldMk cId="0" sldId="266"/>
-            <ac:grpSpMk id="25" creationId="{4A8AA92B-752F-EBA9-7ECB-9A0E7A1901C4}"/>
-          </ac:grpSpMkLst>
-        </pc:grpChg>
-        <pc:grpChg chg="mod">
-          <ac:chgData name="Marcos Maillot" userId="fa14b39d-e966-4ebb-a436-4f96f84b9577" providerId="ADAL" clId="{2D40D906-DE93-44E5-B192-09259B1B360B}" dt="2025-11-25T22:34:28.050" v="42"/>
-          <ac:grpSpMkLst>
-            <pc:docMk/>
-            <pc:sldMk cId="0" sldId="266"/>
-            <ac:grpSpMk id="33" creationId="{E83F67B2-11A4-DC3A-35D4-C6C88C7750EA}"/>
-          </ac:grpSpMkLst>
-        </pc:grpChg>
-        <pc:inkChg chg="add mod">
-          <ac:chgData name="Marcos Maillot" userId="fa14b39d-e966-4ebb-a436-4f96f84b9577" providerId="ADAL" clId="{2D40D906-DE93-44E5-B192-09259B1B360B}" dt="2025-11-25T22:33:52.277" v="14"/>
-          <ac:inkMkLst>
-            <pc:docMk/>
-            <pc:sldMk cId="0" sldId="266"/>
-            <ac:inkMk id="2" creationId="{749EA065-F4B3-D89C-C6BF-FD2E4B91B19B}"/>
-          </ac:inkMkLst>
-        </pc:inkChg>
-        <pc:inkChg chg="add mod">
-          <ac:chgData name="Marcos Maillot" userId="fa14b39d-e966-4ebb-a436-4f96f84b9577" providerId="ADAL" clId="{2D40D906-DE93-44E5-B192-09259B1B360B}" dt="2025-11-25T22:33:52.277" v="14"/>
-          <ac:inkMkLst>
-            <pc:docMk/>
-            <pc:sldMk cId="0" sldId="266"/>
-            <ac:inkMk id="3" creationId="{F7A32831-D49E-E5A1-740B-D6A6AD49D661}"/>
-          </ac:inkMkLst>
-        </pc:inkChg>
-        <pc:inkChg chg="add mod">
-          <ac:chgData name="Marcos Maillot" userId="fa14b39d-e966-4ebb-a436-4f96f84b9577" providerId="ADAL" clId="{2D40D906-DE93-44E5-B192-09259B1B360B}" dt="2025-11-25T22:33:52.277" v="14"/>
-          <ac:inkMkLst>
-            <pc:docMk/>
-            <pc:sldMk cId="0" sldId="266"/>
-            <ac:inkMk id="4" creationId="{95AB81AC-33E0-CA70-B3AC-822775643DA2}"/>
-          </ac:inkMkLst>
-        </pc:inkChg>
-        <pc:inkChg chg="add mod">
-          <ac:chgData name="Marcos Maillot" userId="fa14b39d-e966-4ebb-a436-4f96f84b9577" providerId="ADAL" clId="{2D40D906-DE93-44E5-B192-09259B1B360B}" dt="2025-11-25T22:33:55.490" v="18"/>
-          <ac:inkMkLst>
-            <pc:docMk/>
-            <pc:sldMk cId="0" sldId="266"/>
-            <ac:inkMk id="6" creationId="{EB996B4E-8326-7431-A0CC-CF9E5011D7D2}"/>
-          </ac:inkMkLst>
-        </pc:inkChg>
-        <pc:inkChg chg="add mod">
-          <ac:chgData name="Marcos Maillot" userId="fa14b39d-e966-4ebb-a436-4f96f84b9577" providerId="ADAL" clId="{2D40D906-DE93-44E5-B192-09259B1B360B}" dt="2025-11-25T22:33:55.490" v="18"/>
-          <ac:inkMkLst>
-            <pc:docMk/>
-            <pc:sldMk cId="0" sldId="266"/>
-            <ac:inkMk id="7" creationId="{6B440A2D-6502-282D-0772-27B92454D168}"/>
-          </ac:inkMkLst>
-        </pc:inkChg>
-        <pc:inkChg chg="add mod">
-          <ac:chgData name="Marcos Maillot" userId="fa14b39d-e966-4ebb-a436-4f96f84b9577" providerId="ADAL" clId="{2D40D906-DE93-44E5-B192-09259B1B360B}" dt="2025-11-25T22:33:55.490" v="18"/>
-          <ac:inkMkLst>
-            <pc:docMk/>
-            <pc:sldMk cId="0" sldId="266"/>
-            <ac:inkMk id="8" creationId="{65B89D6B-E590-054E-F8DC-1385A9E629CA}"/>
-          </ac:inkMkLst>
-        </pc:inkChg>
-        <pc:inkChg chg="add mod">
-          <ac:chgData name="Marcos Maillot" userId="fa14b39d-e966-4ebb-a436-4f96f84b9577" providerId="ADAL" clId="{2D40D906-DE93-44E5-B192-09259B1B360B}" dt="2025-11-25T22:34:05.593" v="26"/>
-          <ac:inkMkLst>
-            <pc:docMk/>
-            <pc:sldMk cId="0" sldId="266"/>
-            <ac:inkMk id="10" creationId="{354ABFB8-069D-9988-6F27-2BEFEB0889B6}"/>
-          </ac:inkMkLst>
-        </pc:inkChg>
-        <pc:inkChg chg="add mod">
-          <ac:chgData name="Marcos Maillot" userId="fa14b39d-e966-4ebb-a436-4f96f84b9577" providerId="ADAL" clId="{2D40D906-DE93-44E5-B192-09259B1B360B}" dt="2025-11-25T22:34:05.593" v="26"/>
-          <ac:inkMkLst>
-            <pc:docMk/>
-            <pc:sldMk cId="0" sldId="266"/>
-            <ac:inkMk id="11" creationId="{50DA7574-17C5-6C99-43B4-2ECE4B39C68A}"/>
-          </ac:inkMkLst>
-        </pc:inkChg>
-        <pc:inkChg chg="add mod">
-          <ac:chgData name="Marcos Maillot" userId="fa14b39d-e966-4ebb-a436-4f96f84b9577" providerId="ADAL" clId="{2D40D906-DE93-44E5-B192-09259B1B360B}" dt="2025-11-25T22:34:05.593" v="26"/>
-          <ac:inkMkLst>
-            <pc:docMk/>
-            <pc:sldMk cId="0" sldId="266"/>
-            <ac:inkMk id="12" creationId="{0B433005-565D-2F0C-FBEA-B4FC7FF8BB8E}"/>
-          </ac:inkMkLst>
-        </pc:inkChg>
-        <pc:inkChg chg="add mod">
-          <ac:chgData name="Marcos Maillot" userId="fa14b39d-e966-4ebb-a436-4f96f84b9577" providerId="ADAL" clId="{2D40D906-DE93-44E5-B192-09259B1B360B}" dt="2025-11-25T22:34:05.593" v="26"/>
-          <ac:inkMkLst>
-            <pc:docMk/>
-            <pc:sldMk cId="0" sldId="266"/>
-            <ac:inkMk id="13" creationId="{0A80ED27-2EB5-9407-A644-63A97934BBF1}"/>
-          </ac:inkMkLst>
-        </pc:inkChg>
-        <pc:inkChg chg="add mod">
-          <ac:chgData name="Marcos Maillot" userId="fa14b39d-e966-4ebb-a436-4f96f84b9577" providerId="ADAL" clId="{2D40D906-DE93-44E5-B192-09259B1B360B}" dt="2025-11-25T22:34:05.593" v="26"/>
-          <ac:inkMkLst>
-            <pc:docMk/>
-            <pc:sldMk cId="0" sldId="266"/>
-            <ac:inkMk id="14" creationId="{B12C391F-C6FB-FE34-F95A-B33B228A3401}"/>
-          </ac:inkMkLst>
-        </pc:inkChg>
-        <pc:inkChg chg="add mod">
-          <ac:chgData name="Marcos Maillot" userId="fa14b39d-e966-4ebb-a436-4f96f84b9577" providerId="ADAL" clId="{2D40D906-DE93-44E5-B192-09259B1B360B}" dt="2025-11-25T22:34:05.593" v="26"/>
-          <ac:inkMkLst>
-            <pc:docMk/>
-            <pc:sldMk cId="0" sldId="266"/>
-            <ac:inkMk id="15" creationId="{F881FBEA-F7F6-EDCD-8A54-B7938F2AF962}"/>
-          </ac:inkMkLst>
-        </pc:inkChg>
-        <pc:inkChg chg="add mod">
-          <ac:chgData name="Marcos Maillot" userId="fa14b39d-e966-4ebb-a436-4f96f84b9577" providerId="ADAL" clId="{2D40D906-DE93-44E5-B192-09259B1B360B}" dt="2025-11-25T22:34:05.593" v="26"/>
-          <ac:inkMkLst>
-            <pc:docMk/>
-            <pc:sldMk cId="0" sldId="266"/>
-            <ac:inkMk id="16" creationId="{DB79B9E8-AEF7-B9BB-A04E-742C1E87A784}"/>
-          </ac:inkMkLst>
-        </pc:inkChg>
-        <pc:inkChg chg="add mod">
-          <ac:chgData name="Marcos Maillot" userId="fa14b39d-e966-4ebb-a436-4f96f84b9577" providerId="ADAL" clId="{2D40D906-DE93-44E5-B192-09259B1B360B}" dt="2025-11-25T22:34:18.445" v="34"/>
-          <ac:inkMkLst>
-            <pc:docMk/>
-            <pc:sldMk cId="0" sldId="266"/>
-            <ac:inkMk id="18" creationId="{BAB136AA-CBCB-FFB0-79A6-6D0DB2EB186D}"/>
-          </ac:inkMkLst>
-        </pc:inkChg>
-        <pc:inkChg chg="add mod">
-          <ac:chgData name="Marcos Maillot" userId="fa14b39d-e966-4ebb-a436-4f96f84b9577" providerId="ADAL" clId="{2D40D906-DE93-44E5-B192-09259B1B360B}" dt="2025-11-25T22:34:18.445" v="34"/>
-          <ac:inkMkLst>
-            <pc:docMk/>
-            <pc:sldMk cId="0" sldId="266"/>
-            <ac:inkMk id="19" creationId="{5EA59B0B-2A7C-7F14-FCD7-7F969EE3DB39}"/>
-          </ac:inkMkLst>
-        </pc:inkChg>
-        <pc:inkChg chg="add mod">
-          <ac:chgData name="Marcos Maillot" userId="fa14b39d-e966-4ebb-a436-4f96f84b9577" providerId="ADAL" clId="{2D40D906-DE93-44E5-B192-09259B1B360B}" dt="2025-11-25T22:34:18.445" v="34"/>
-          <ac:inkMkLst>
-            <pc:docMk/>
-            <pc:sldMk cId="0" sldId="266"/>
-            <ac:inkMk id="20" creationId="{E4701377-24DC-DA18-30EE-1BEF89B087EC}"/>
-          </ac:inkMkLst>
-        </pc:inkChg>
-        <pc:inkChg chg="add mod">
-          <ac:chgData name="Marcos Maillot" userId="fa14b39d-e966-4ebb-a436-4f96f84b9577" providerId="ADAL" clId="{2D40D906-DE93-44E5-B192-09259B1B360B}" dt="2025-11-25T22:34:18.445" v="34"/>
-          <ac:inkMkLst>
-            <pc:docMk/>
-            <pc:sldMk cId="0" sldId="266"/>
-            <ac:inkMk id="21" creationId="{198174FD-11AF-F283-AE79-1783E172E43C}"/>
-          </ac:inkMkLst>
-        </pc:inkChg>
-        <pc:inkChg chg="add mod">
-          <ac:chgData name="Marcos Maillot" userId="fa14b39d-e966-4ebb-a436-4f96f84b9577" providerId="ADAL" clId="{2D40D906-DE93-44E5-B192-09259B1B360B}" dt="2025-11-25T22:34:18.445" v="34"/>
-          <ac:inkMkLst>
-            <pc:docMk/>
-            <pc:sldMk cId="0" sldId="266"/>
-            <ac:inkMk id="22" creationId="{FB9E2EA7-7B16-C1BC-035E-D25F327B00AD}"/>
-          </ac:inkMkLst>
-        </pc:inkChg>
-        <pc:inkChg chg="add mod">
-          <ac:chgData name="Marcos Maillot" userId="fa14b39d-e966-4ebb-a436-4f96f84b9577" providerId="ADAL" clId="{2D40D906-DE93-44E5-B192-09259B1B360B}" dt="2025-11-25T22:34:18.445" v="34"/>
-          <ac:inkMkLst>
-            <pc:docMk/>
-            <pc:sldMk cId="0" sldId="266"/>
-            <ac:inkMk id="23" creationId="{7EE23F2D-29A7-6C28-98CA-4B16CFD01903}"/>
-          </ac:inkMkLst>
-        </pc:inkChg>
-        <pc:inkChg chg="add mod">
-          <ac:chgData name="Marcos Maillot" userId="fa14b39d-e966-4ebb-a436-4f96f84b9577" providerId="ADAL" clId="{2D40D906-DE93-44E5-B192-09259B1B360B}" dt="2025-11-25T22:34:18.445" v="34"/>
-          <ac:inkMkLst>
-            <pc:docMk/>
-            <pc:sldMk cId="0" sldId="266"/>
-            <ac:inkMk id="24" creationId="{6B538EDD-8461-5F69-84F1-06D58E86DED2}"/>
-          </ac:inkMkLst>
-        </pc:inkChg>
-        <pc:inkChg chg="add mod">
-          <ac:chgData name="Marcos Maillot" userId="fa14b39d-e966-4ebb-a436-4f96f84b9577" providerId="ADAL" clId="{2D40D906-DE93-44E5-B192-09259B1B360B}" dt="2025-11-25T22:34:28.050" v="42"/>
-          <ac:inkMkLst>
-            <pc:docMk/>
-            <pc:sldMk cId="0" sldId="266"/>
-            <ac:inkMk id="26" creationId="{AE88D445-AD00-6C8C-B596-653D36915467}"/>
-          </ac:inkMkLst>
-        </pc:inkChg>
-        <pc:inkChg chg="add mod">
-          <ac:chgData name="Marcos Maillot" userId="fa14b39d-e966-4ebb-a436-4f96f84b9577" providerId="ADAL" clId="{2D40D906-DE93-44E5-B192-09259B1B360B}" dt="2025-11-25T22:34:28.050" v="42"/>
-          <ac:inkMkLst>
-            <pc:docMk/>
-            <pc:sldMk cId="0" sldId="266"/>
-            <ac:inkMk id="27" creationId="{AF7C1D39-74E8-3D51-5A18-06ECB0FC875B}"/>
-          </ac:inkMkLst>
-        </pc:inkChg>
-        <pc:inkChg chg="add mod">
-          <ac:chgData name="Marcos Maillot" userId="fa14b39d-e966-4ebb-a436-4f96f84b9577" providerId="ADAL" clId="{2D40D906-DE93-44E5-B192-09259B1B360B}" dt="2025-11-25T22:34:28.050" v="42"/>
-          <ac:inkMkLst>
-            <pc:docMk/>
-            <pc:sldMk cId="0" sldId="266"/>
-            <ac:inkMk id="28" creationId="{E26FA917-5F06-3B61-0489-1FF30CCBE52D}"/>
-          </ac:inkMkLst>
-        </pc:inkChg>
-        <pc:inkChg chg="add mod">
-          <ac:chgData name="Marcos Maillot" userId="fa14b39d-e966-4ebb-a436-4f96f84b9577" providerId="ADAL" clId="{2D40D906-DE93-44E5-B192-09259B1B360B}" dt="2025-11-25T22:34:28.050" v="42"/>
-          <ac:inkMkLst>
-            <pc:docMk/>
-            <pc:sldMk cId="0" sldId="266"/>
-            <ac:inkMk id="29" creationId="{0E8897D8-0A2D-5391-3B1E-6720A8FFA9A2}"/>
-          </ac:inkMkLst>
-        </pc:inkChg>
-        <pc:inkChg chg="add mod">
-          <ac:chgData name="Marcos Maillot" userId="fa14b39d-e966-4ebb-a436-4f96f84b9577" providerId="ADAL" clId="{2D40D906-DE93-44E5-B192-09259B1B360B}" dt="2025-11-25T22:34:28.050" v="42"/>
-          <ac:inkMkLst>
-            <pc:docMk/>
-            <pc:sldMk cId="0" sldId="266"/>
-            <ac:inkMk id="30" creationId="{7F562EC2-D702-04DA-B7D6-D454DC4389B6}"/>
-          </ac:inkMkLst>
-        </pc:inkChg>
-        <pc:inkChg chg="add mod">
-          <ac:chgData name="Marcos Maillot" userId="fa14b39d-e966-4ebb-a436-4f96f84b9577" providerId="ADAL" clId="{2D40D906-DE93-44E5-B192-09259B1B360B}" dt="2025-11-25T22:34:28.050" v="42"/>
-          <ac:inkMkLst>
-            <pc:docMk/>
-            <pc:sldMk cId="0" sldId="266"/>
-            <ac:inkMk id="31" creationId="{9A388E52-968D-A4EE-6938-7979C37C684A}"/>
-          </ac:inkMkLst>
-        </pc:inkChg>
-        <pc:inkChg chg="add mod">
-          <ac:chgData name="Marcos Maillot" userId="fa14b39d-e966-4ebb-a436-4f96f84b9577" providerId="ADAL" clId="{2D40D906-DE93-44E5-B192-09259B1B360B}" dt="2025-11-25T22:34:28.050" v="42"/>
-          <ac:inkMkLst>
-            <pc:docMk/>
-            <pc:sldMk cId="0" sldId="266"/>
-            <ac:inkMk id="32" creationId="{1E29C693-E48F-FFF4-167A-0FE18D904F50}"/>
-          </ac:inkMkLst>
-        </pc:inkChg>
-      </pc:sldChg>
-      <pc:sldChg chg="addSp delSp modSp mod">
-        <pc:chgData name="Marcos Maillot" userId="fa14b39d-e966-4ebb-a436-4f96f84b9577" providerId="ADAL" clId="{2D40D906-DE93-44E5-B192-09259B1B360B}" dt="2025-11-25T23:03:19.310" v="64" actId="478"/>
-        <pc:sldMkLst>
-          <pc:docMk/>
-          <pc:sldMk cId="0" sldId="267"/>
-        </pc:sldMkLst>
-        <pc:grpChg chg="del mod">
-          <ac:chgData name="Marcos Maillot" userId="fa14b39d-e966-4ebb-a436-4f96f84b9577" providerId="ADAL" clId="{2D40D906-DE93-44E5-B192-09259B1B360B}" dt="2025-11-25T22:39:16.356" v="55"/>
-          <ac:grpSpMkLst>
-            <pc:docMk/>
-            <pc:sldMk cId="0" sldId="267"/>
-            <ac:grpSpMk id="9" creationId="{5DB8CC21-5AE5-1647-BB62-D7E5188D8C67}"/>
-          </ac:grpSpMkLst>
-        </pc:grpChg>
-        <pc:grpChg chg="del mod">
-          <ac:chgData name="Marcos Maillot" userId="fa14b39d-e966-4ebb-a436-4f96f84b9577" providerId="ADAL" clId="{2D40D906-DE93-44E5-B192-09259B1B360B}" dt="2025-11-25T22:39:18.370" v="57"/>
-          <ac:grpSpMkLst>
-            <pc:docMk/>
-            <pc:sldMk cId="0" sldId="267"/>
-            <ac:grpSpMk id="14" creationId="{9EA8FD0A-C494-73DF-A933-A34E6FBDA3FB}"/>
-          </ac:grpSpMkLst>
-        </pc:grpChg>
-        <pc:grpChg chg="del mod">
-          <ac:chgData name="Marcos Maillot" userId="fa14b39d-e966-4ebb-a436-4f96f84b9577" providerId="ADAL" clId="{2D40D906-DE93-44E5-B192-09259B1B360B}" dt="2025-11-25T22:39:23.334" v="63"/>
-          <ac:grpSpMkLst>
-            <pc:docMk/>
-            <pc:sldMk cId="0" sldId="267"/>
-            <ac:grpSpMk id="16" creationId="{3BFAA7E9-394D-8F07-0AE5-7D35064944A1}"/>
-          </ac:grpSpMkLst>
-        </pc:grpChg>
-        <pc:grpChg chg="del mod">
-          <ac:chgData name="Marcos Maillot" userId="fa14b39d-e966-4ebb-a436-4f96f84b9577" providerId="ADAL" clId="{2D40D906-DE93-44E5-B192-09259B1B360B}" dt="2025-11-25T23:03:19.310" v="64" actId="478"/>
-          <ac:grpSpMkLst>
-            <pc:docMk/>
-            <pc:sldMk cId="0" sldId="267"/>
-            <ac:grpSpMk id="22" creationId="{BD5F8BCD-DEC0-1EAB-2632-013FEFCD1CAD}"/>
-          </ac:grpSpMkLst>
-        </pc:grpChg>
-        <pc:inkChg chg="add mod">
-          <ac:chgData name="Marcos Maillot" userId="fa14b39d-e966-4ebb-a436-4f96f84b9577" providerId="ADAL" clId="{2D40D906-DE93-44E5-B192-09259B1B360B}" dt="2025-11-25T22:39:23.334" v="63"/>
-          <ac:inkMkLst>
-            <pc:docMk/>
-            <pc:sldMk cId="0" sldId="267"/>
-            <ac:inkMk id="2" creationId="{48AF801C-C277-7B5D-94EE-4C561A8B7B60}"/>
-          </ac:inkMkLst>
-        </pc:inkChg>
-        <pc:inkChg chg="add mod">
-          <ac:chgData name="Marcos Maillot" userId="fa14b39d-e966-4ebb-a436-4f96f84b9577" providerId="ADAL" clId="{2D40D906-DE93-44E5-B192-09259B1B360B}" dt="2025-11-25T22:39:14.153" v="50"/>
-          <ac:inkMkLst>
-            <pc:docMk/>
-            <pc:sldMk cId="0" sldId="267"/>
-            <ac:inkMk id="3" creationId="{FC925376-AC82-CDDD-3234-47B2A9F95D94}"/>
-          </ac:inkMkLst>
-        </pc:inkChg>
-        <pc:inkChg chg="add mod">
-          <ac:chgData name="Marcos Maillot" userId="fa14b39d-e966-4ebb-a436-4f96f84b9577" providerId="ADAL" clId="{2D40D906-DE93-44E5-B192-09259B1B360B}" dt="2025-11-25T22:39:18.370" v="57"/>
-          <ac:inkMkLst>
-            <pc:docMk/>
-            <pc:sldMk cId="0" sldId="267"/>
-            <ac:inkMk id="4" creationId="{03A0C848-4C20-F17A-7678-FF746F45A396}"/>
-          </ac:inkMkLst>
-        </pc:inkChg>
-        <pc:inkChg chg="add mod">
-          <ac:chgData name="Marcos Maillot" userId="fa14b39d-e966-4ebb-a436-4f96f84b9577" providerId="ADAL" clId="{2D40D906-DE93-44E5-B192-09259B1B360B}" dt="2025-11-25T22:39:16.356" v="55"/>
-          <ac:inkMkLst>
-            <pc:docMk/>
-            <pc:sldMk cId="0" sldId="267"/>
-            <ac:inkMk id="5" creationId="{3FA9A26D-4127-DF0B-F399-ABA4311244DA}"/>
-          </ac:inkMkLst>
-        </pc:inkChg>
-        <pc:inkChg chg="add mod">
-          <ac:chgData name="Marcos Maillot" userId="fa14b39d-e966-4ebb-a436-4f96f84b9577" providerId="ADAL" clId="{2D40D906-DE93-44E5-B192-09259B1B360B}" dt="2025-11-25T22:39:18.370" v="57"/>
-          <ac:inkMkLst>
-            <pc:docMk/>
-            <pc:sldMk cId="0" sldId="267"/>
-            <ac:inkMk id="6" creationId="{61C0CE80-FE9A-FDA2-D759-518E8429486F}"/>
-          </ac:inkMkLst>
-        </pc:inkChg>
-        <pc:inkChg chg="add mod">
-          <ac:chgData name="Marcos Maillot" userId="fa14b39d-e966-4ebb-a436-4f96f84b9577" providerId="ADAL" clId="{2D40D906-DE93-44E5-B192-09259B1B360B}" dt="2025-11-25T22:39:23.334" v="63"/>
-          <ac:inkMkLst>
-            <pc:docMk/>
-            <pc:sldMk cId="0" sldId="267"/>
-            <ac:inkMk id="7" creationId="{D1B90627-A143-82F5-6D51-90B60E119BF0}"/>
-          </ac:inkMkLst>
-        </pc:inkChg>
-        <pc:inkChg chg="add mod">
-          <ac:chgData name="Marcos Maillot" userId="fa14b39d-e966-4ebb-a436-4f96f84b9577" providerId="ADAL" clId="{2D40D906-DE93-44E5-B192-09259B1B360B}" dt="2025-11-25T22:39:23.334" v="63"/>
-          <ac:inkMkLst>
-            <pc:docMk/>
-            <pc:sldMk cId="0" sldId="267"/>
-            <ac:inkMk id="8" creationId="{420B8764-15CA-DDE8-EFCE-857C65984C59}"/>
-          </ac:inkMkLst>
-        </pc:inkChg>
-        <pc:inkChg chg="add mod">
-          <ac:chgData name="Marcos Maillot" userId="fa14b39d-e966-4ebb-a436-4f96f84b9577" providerId="ADAL" clId="{2D40D906-DE93-44E5-B192-09259B1B360B}" dt="2025-11-25T22:39:23.334" v="63"/>
-          <ac:inkMkLst>
-            <pc:docMk/>
-            <pc:sldMk cId="0" sldId="267"/>
-            <ac:inkMk id="10" creationId="{91A4C169-8A1D-8CEB-D927-5765DD8E859C}"/>
-          </ac:inkMkLst>
-        </pc:inkChg>
-        <pc:inkChg chg="add mod">
-          <ac:chgData name="Marcos Maillot" userId="fa14b39d-e966-4ebb-a436-4f96f84b9577" providerId="ADAL" clId="{2D40D906-DE93-44E5-B192-09259B1B360B}" dt="2025-11-25T22:39:23.334" v="63"/>
-          <ac:inkMkLst>
-            <pc:docMk/>
-            <pc:sldMk cId="0" sldId="267"/>
-            <ac:inkMk id="11" creationId="{7DF62D9A-A8B4-8931-EBEB-8C21133AD392}"/>
-          </ac:inkMkLst>
-        </pc:inkChg>
-        <pc:inkChg chg="add mod">
-          <ac:chgData name="Marcos Maillot" userId="fa14b39d-e966-4ebb-a436-4f96f84b9577" providerId="ADAL" clId="{2D40D906-DE93-44E5-B192-09259B1B360B}" dt="2025-11-25T22:39:18.370" v="57"/>
-          <ac:inkMkLst>
-            <pc:docMk/>
-            <pc:sldMk cId="0" sldId="267"/>
-            <ac:inkMk id="12" creationId="{111AB01B-11DD-5729-8D45-336E61F5DAF3}"/>
-          </ac:inkMkLst>
-        </pc:inkChg>
-        <pc:inkChg chg="add mod">
-          <ac:chgData name="Marcos Maillot" userId="fa14b39d-e966-4ebb-a436-4f96f84b9577" providerId="ADAL" clId="{2D40D906-DE93-44E5-B192-09259B1B360B}" dt="2025-11-25T22:39:16.356" v="55"/>
-          <ac:inkMkLst>
-            <pc:docMk/>
-            <pc:sldMk cId="0" sldId="267"/>
-            <ac:inkMk id="13" creationId="{DC244B66-4EB9-C2BF-E556-01A6470FCACD}"/>
-          </ac:inkMkLst>
-        </pc:inkChg>
-        <pc:inkChg chg="add">
-          <ac:chgData name="Marcos Maillot" userId="fa14b39d-e966-4ebb-a436-4f96f84b9577" providerId="ADAL" clId="{2D40D906-DE93-44E5-B192-09259B1B360B}" dt="2025-11-25T22:39:17.410" v="56" actId="9405"/>
-          <ac:inkMkLst>
-            <pc:docMk/>
-            <pc:sldMk cId="0" sldId="267"/>
-            <ac:inkMk id="15" creationId="{EEABD1C4-920E-4673-EEC2-3C86BEF604B3}"/>
-          </ac:inkMkLst>
-        </pc:inkChg>
-        <pc:inkChg chg="add mod">
-          <ac:chgData name="Marcos Maillot" userId="fa14b39d-e966-4ebb-a436-4f96f84b9577" providerId="ADAL" clId="{2D40D906-DE93-44E5-B192-09259B1B360B}" dt="2025-11-25T22:39:23.334" v="63"/>
-          <ac:inkMkLst>
-            <pc:docMk/>
-            <pc:sldMk cId="0" sldId="267"/>
-            <ac:inkMk id="17" creationId="{CC86826D-7437-DE95-6277-E9BE81ABB7B7}"/>
-          </ac:inkMkLst>
-        </pc:inkChg>
-        <pc:inkChg chg="add mod">
-          <ac:chgData name="Marcos Maillot" userId="fa14b39d-e966-4ebb-a436-4f96f84b9577" providerId="ADAL" clId="{2D40D906-DE93-44E5-B192-09259B1B360B}" dt="2025-11-25T22:39:23.334" v="63"/>
-          <ac:inkMkLst>
-            <pc:docMk/>
-            <pc:sldMk cId="0" sldId="267"/>
-            <ac:inkMk id="18" creationId="{38F766ED-2CCD-3CAC-5FD8-F63ABDDE99FB}"/>
-          </ac:inkMkLst>
-        </pc:inkChg>
-        <pc:inkChg chg="add">
-          <ac:chgData name="Marcos Maillot" userId="fa14b39d-e966-4ebb-a436-4f96f84b9577" providerId="ADAL" clId="{2D40D906-DE93-44E5-B192-09259B1B360B}" dt="2025-11-25T22:39:20.413" v="60" actId="9405"/>
-          <ac:inkMkLst>
-            <pc:docMk/>
-            <pc:sldMk cId="0" sldId="267"/>
-            <ac:inkMk id="19" creationId="{0E60353F-A197-8EE2-C926-A2486AD2E065}"/>
-          </ac:inkMkLst>
-        </pc:inkChg>
-        <pc:inkChg chg="add">
-          <ac:chgData name="Marcos Maillot" userId="fa14b39d-e966-4ebb-a436-4f96f84b9577" providerId="ADAL" clId="{2D40D906-DE93-44E5-B192-09259B1B360B}" dt="2025-11-25T22:39:21.429" v="61" actId="9405"/>
-          <ac:inkMkLst>
-            <pc:docMk/>
-            <pc:sldMk cId="0" sldId="267"/>
-            <ac:inkMk id="20" creationId="{C0776E63-B6D6-0C88-DA50-BF608D84B31B}"/>
-          </ac:inkMkLst>
-        </pc:inkChg>
-        <pc:inkChg chg="add mod">
-          <ac:chgData name="Marcos Maillot" userId="fa14b39d-e966-4ebb-a436-4f96f84b9577" providerId="ADAL" clId="{2D40D906-DE93-44E5-B192-09259B1B360B}" dt="2025-11-25T22:39:23.334" v="63"/>
-          <ac:inkMkLst>
-            <pc:docMk/>
-            <pc:sldMk cId="0" sldId="267"/>
-            <ac:inkMk id="21" creationId="{26C2DB75-A41B-DF53-F935-042342A1FA6C}"/>
-          </ac:inkMkLst>
-        </pc:inkChg>
-      </pc:sldChg>
-      <pc:sldChg chg="modSp mod">
-        <pc:chgData name="Marcos Maillot" userId="fa14b39d-e966-4ebb-a436-4f96f84b9577" providerId="ADAL" clId="{2D40D906-DE93-44E5-B192-09259B1B360B}" dt="2025-11-25T22:30:23.637" v="10" actId="20577"/>
-        <pc:sldMkLst>
-          <pc:docMk/>
-          <pc:sldMk cId="0" sldId="268"/>
-        </pc:sldMkLst>
-        <pc:graphicFrameChg chg="modGraphic">
-          <ac:chgData name="Marcos Maillot" userId="fa14b39d-e966-4ebb-a436-4f96f84b9577" providerId="ADAL" clId="{2D40D906-DE93-44E5-B192-09259B1B360B}" dt="2025-11-25T22:30:23.637" v="10" actId="20577"/>
-          <ac:graphicFrameMkLst>
-            <pc:docMk/>
-            <pc:sldMk cId="0" sldId="268"/>
-            <ac:graphicFrameMk id="198" creationId="{00000000-0000-0000-0000-000000000000}"/>
-          </ac:graphicFrameMkLst>
-        </pc:graphicFrameChg>
-      </pc:sldChg>
-      <pc:sldChg chg="delSp mod">
-        <pc:chgData name="Marcos Maillot" userId="fa14b39d-e966-4ebb-a436-4f96f84b9577" providerId="ADAL" clId="{2D40D906-DE93-44E5-B192-09259B1B360B}" dt="2025-11-25T19:48:12.282" v="9" actId="478"/>
-        <pc:sldMkLst>
-          <pc:docMk/>
-          <pc:sldMk cId="0" sldId="285"/>
-        </pc:sldMkLst>
-        <pc:grpChg chg="del">
-          <ac:chgData name="Marcos Maillot" userId="fa14b39d-e966-4ebb-a436-4f96f84b9577" providerId="ADAL" clId="{2D40D906-DE93-44E5-B192-09259B1B360B}" dt="2025-11-25T19:48:10.804" v="8" actId="478"/>
-          <ac:grpSpMkLst>
-            <pc:docMk/>
-            <pc:sldMk cId="0" sldId="285"/>
-            <ac:grpSpMk id="15" creationId="{28889A49-5EF9-E12C-E967-7AD063E5145F}"/>
-          </ac:grpSpMkLst>
-        </pc:grpChg>
-        <pc:inkChg chg="del">
-          <ac:chgData name="Marcos Maillot" userId="fa14b39d-e966-4ebb-a436-4f96f84b9577" providerId="ADAL" clId="{2D40D906-DE93-44E5-B192-09259B1B360B}" dt="2025-11-25T19:47:36.615" v="7" actId="478"/>
-          <ac:inkMkLst>
-            <pc:docMk/>
-            <pc:sldMk cId="0" sldId="285"/>
-            <ac:inkMk id="3" creationId="{6E22F2DF-6723-A24B-2D8C-CCDA2641AF23}"/>
-          </ac:inkMkLst>
-        </pc:inkChg>
-        <pc:inkChg chg="del">
-          <ac:chgData name="Marcos Maillot" userId="fa14b39d-e966-4ebb-a436-4f96f84b9577" providerId="ADAL" clId="{2D40D906-DE93-44E5-B192-09259B1B360B}" dt="2025-11-25T19:48:12.282" v="9" actId="478"/>
-          <ac:inkMkLst>
-            <pc:docMk/>
-            <pc:sldMk cId="0" sldId="285"/>
-            <ac:inkMk id="7" creationId="{0FE5F255-1F1C-DCF8-CAEE-5567C6A5E19B}"/>
-          </ac:inkMkLst>
-        </pc:inkChg>
-        <pc:inkChg chg="del">
-          <ac:chgData name="Marcos Maillot" userId="fa14b39d-e966-4ebb-a436-4f96f84b9577" providerId="ADAL" clId="{2D40D906-DE93-44E5-B192-09259B1B360B}" dt="2025-11-25T19:47:33.262" v="6" actId="478"/>
-          <ac:inkMkLst>
-            <pc:docMk/>
-            <pc:sldMk cId="0" sldId="285"/>
-            <ac:inkMk id="9" creationId="{7639F04C-BBC4-0C61-72E9-98EB66BE33AA}"/>
-          </ac:inkMkLst>
-        </pc:inkChg>
-      </pc:sldChg>
-      <pc:sldChg chg="addSp delSp modSp mod">
-        <pc:chgData name="Marcos Maillot" userId="fa14b39d-e966-4ebb-a436-4f96f84b9577" providerId="ADAL" clId="{2D40D906-DE93-44E5-B192-09259B1B360B}" dt="2025-11-26T00:59:33.472" v="217"/>
-        <pc:sldMkLst>
-          <pc:docMk/>
-          <pc:sldMk cId="0" sldId="286"/>
-        </pc:sldMkLst>
-        <pc:grpChg chg="del mod">
-          <ac:chgData name="Marcos Maillot" userId="fa14b39d-e966-4ebb-a436-4f96f84b9577" providerId="ADAL" clId="{2D40D906-DE93-44E5-B192-09259B1B360B}" dt="2025-11-26T00:58:56.878" v="185"/>
-          <ac:grpSpMkLst>
-            <pc:docMk/>
-            <pc:sldMk cId="0" sldId="286"/>
-            <ac:grpSpMk id="6" creationId="{96FEF218-0F63-17FF-ACF2-4D6BC44C0EE5}"/>
-          </ac:grpSpMkLst>
-        </pc:grpChg>
-        <pc:grpChg chg="del mod">
-          <ac:chgData name="Marcos Maillot" userId="fa14b39d-e966-4ebb-a436-4f96f84b9577" providerId="ADAL" clId="{2D40D906-DE93-44E5-B192-09259B1B360B}" dt="2025-11-26T00:59:02.653" v="193"/>
-          <ac:grpSpMkLst>
-            <pc:docMk/>
-            <pc:sldMk cId="0" sldId="286"/>
-            <ac:grpSpMk id="9" creationId="{0DB58671-4A57-BD6B-9220-F92C770CCEE2}"/>
-          </ac:grpSpMkLst>
-        </pc:grpChg>
-        <pc:grpChg chg="del mod">
-          <ac:chgData name="Marcos Maillot" userId="fa14b39d-e966-4ebb-a436-4f96f84b9577" providerId="ADAL" clId="{2D40D906-DE93-44E5-B192-09259B1B360B}" dt="2025-11-26T00:59:19.355" v="208"/>
-          <ac:grpSpMkLst>
-            <pc:docMk/>
-            <pc:sldMk cId="0" sldId="286"/>
-            <ac:grpSpMk id="17" creationId="{A2648AAC-053D-0EA4-6B11-FF50C157CEDB}"/>
-          </ac:grpSpMkLst>
-        </pc:grpChg>
-        <pc:grpChg chg="del mod">
-          <ac:chgData name="Marcos Maillot" userId="fa14b39d-e966-4ebb-a436-4f96f84b9577" providerId="ADAL" clId="{2D40D906-DE93-44E5-B192-09259B1B360B}" dt="2025-11-26T00:59:19.355" v="208"/>
-          <ac:grpSpMkLst>
-            <pc:docMk/>
-            <pc:sldMk cId="0" sldId="286"/>
-            <ac:grpSpMk id="26" creationId="{1D0C4B9B-3DDA-C5A7-6752-C204C4D67B4B}"/>
-          </ac:grpSpMkLst>
-        </pc:grpChg>
-        <pc:grpChg chg="del mod">
-          <ac:chgData name="Marcos Maillot" userId="fa14b39d-e966-4ebb-a436-4f96f84b9577" providerId="ADAL" clId="{2D40D906-DE93-44E5-B192-09259B1B360B}" dt="2025-11-26T00:59:33.472" v="217"/>
-          <ac:grpSpMkLst>
-            <pc:docMk/>
-            <pc:sldMk cId="0" sldId="286"/>
-            <ac:grpSpMk id="32" creationId="{D3E0FBEC-24F5-BEB4-58CC-85C7E8EAEC7E}"/>
-          </ac:grpSpMkLst>
-        </pc:grpChg>
-        <pc:grpChg chg="del mod">
-          <ac:chgData name="Marcos Maillot" userId="fa14b39d-e966-4ebb-a436-4f96f84b9577" providerId="ADAL" clId="{2D40D906-DE93-44E5-B192-09259B1B360B}" dt="2025-11-26T00:59:23.338" v="210"/>
-          <ac:grpSpMkLst>
-            <pc:docMk/>
-            <pc:sldMk cId="0" sldId="286"/>
-            <ac:grpSpMk id="33" creationId="{CDB5EDC8-3528-C49E-D596-569F649B6C24}"/>
-          </ac:grpSpMkLst>
-        </pc:grpChg>
-        <pc:grpChg chg="del mod">
-          <ac:chgData name="Marcos Maillot" userId="fa14b39d-e966-4ebb-a436-4f96f84b9577" providerId="ADAL" clId="{2D40D906-DE93-44E5-B192-09259B1B360B}" dt="2025-11-26T00:59:25.817" v="214"/>
-          <ac:grpSpMkLst>
-            <pc:docMk/>
-            <pc:sldMk cId="0" sldId="286"/>
-            <ac:grpSpMk id="35" creationId="{5F9CDD09-F242-F6F1-0214-4FA91E6BE78F}"/>
-          </ac:grpSpMkLst>
-        </pc:grpChg>
-        <pc:grpChg chg="mod">
-          <ac:chgData name="Marcos Maillot" userId="fa14b39d-e966-4ebb-a436-4f96f84b9577" providerId="ADAL" clId="{2D40D906-DE93-44E5-B192-09259B1B360B}" dt="2025-11-26T00:59:25.817" v="214"/>
-          <ac:grpSpMkLst>
-            <pc:docMk/>
-            <pc:sldMk cId="0" sldId="286"/>
-            <ac:grpSpMk id="39" creationId="{41EF43CE-9E30-E7B2-B341-86A8C9F1D82D}"/>
-          </ac:grpSpMkLst>
-        </pc:grpChg>
-        <pc:grpChg chg="mod">
-          <ac:chgData name="Marcos Maillot" userId="fa14b39d-e966-4ebb-a436-4f96f84b9577" providerId="ADAL" clId="{2D40D906-DE93-44E5-B192-09259B1B360B}" dt="2025-11-26T00:59:33.472" v="217"/>
-          <ac:grpSpMkLst>
-            <pc:docMk/>
-            <pc:sldMk cId="0" sldId="286"/>
-            <ac:grpSpMk id="42" creationId="{80CABFA6-55FC-3CB0-1C51-A55B466B24FB}"/>
-          </ac:grpSpMkLst>
-        </pc:grpChg>
-        <pc:inkChg chg="add mod">
-          <ac:chgData name="Marcos Maillot" userId="fa14b39d-e966-4ebb-a436-4f96f84b9577" providerId="ADAL" clId="{2D40D906-DE93-44E5-B192-09259B1B360B}" dt="2025-11-26T00:59:33.472" v="217"/>
-          <ac:inkMkLst>
-            <pc:docMk/>
-            <pc:sldMk cId="0" sldId="286"/>
-            <ac:inkMk id="2" creationId="{C4D4ECF9-8CB1-7F96-C174-FB7EE536572C}"/>
-          </ac:inkMkLst>
-        </pc:inkChg>
-        <pc:inkChg chg="add mod">
-          <ac:chgData name="Marcos Maillot" userId="fa14b39d-e966-4ebb-a436-4f96f84b9577" providerId="ADAL" clId="{2D40D906-DE93-44E5-B192-09259B1B360B}" dt="2025-11-26T00:59:19.355" v="208"/>
-          <ac:inkMkLst>
-            <pc:docMk/>
-            <pc:sldMk cId="0" sldId="286"/>
-            <ac:inkMk id="3" creationId="{B7B8DB0E-DCA5-5F0C-EC38-5EC886F83336}"/>
-          </ac:inkMkLst>
-        </pc:inkChg>
-        <pc:inkChg chg="add mod">
-          <ac:chgData name="Marcos Maillot" userId="fa14b39d-e966-4ebb-a436-4f96f84b9577" providerId="ADAL" clId="{2D40D906-DE93-44E5-B192-09259B1B360B}" dt="2025-11-26T00:59:33.472" v="217"/>
-          <ac:inkMkLst>
-            <pc:docMk/>
-            <pc:sldMk cId="0" sldId="286"/>
-            <ac:inkMk id="4" creationId="{1F587C21-CC89-159B-06E0-15AEB05EDA26}"/>
-          </ac:inkMkLst>
-        </pc:inkChg>
-        <pc:inkChg chg="add mod">
-          <ac:chgData name="Marcos Maillot" userId="fa14b39d-e966-4ebb-a436-4f96f84b9577" providerId="ADAL" clId="{2D40D906-DE93-44E5-B192-09259B1B360B}" dt="2025-11-26T00:59:33.472" v="217"/>
-          <ac:inkMkLst>
-            <pc:docMk/>
-            <pc:sldMk cId="0" sldId="286"/>
-            <ac:inkMk id="5" creationId="{86741D29-E7E2-773A-3980-46014B81B338}"/>
-          </ac:inkMkLst>
-        </pc:inkChg>
-        <pc:inkChg chg="add mod">
-          <ac:chgData name="Marcos Maillot" userId="fa14b39d-e966-4ebb-a436-4f96f84b9577" providerId="ADAL" clId="{2D40D906-DE93-44E5-B192-09259B1B360B}" dt="2025-11-26T00:58:56.878" v="185"/>
-          <ac:inkMkLst>
-            <pc:docMk/>
-            <pc:sldMk cId="0" sldId="286"/>
-            <ac:inkMk id="7" creationId="{E1855472-5AB9-E7EB-85E9-81430A639475}"/>
-          </ac:inkMkLst>
-        </pc:inkChg>
-        <pc:inkChg chg="add mod">
-          <ac:chgData name="Marcos Maillot" userId="fa14b39d-e966-4ebb-a436-4f96f84b9577" providerId="ADAL" clId="{2D40D906-DE93-44E5-B192-09259B1B360B}" dt="2025-11-26T00:58:56.878" v="185"/>
-          <ac:inkMkLst>
-            <pc:docMk/>
-            <pc:sldMk cId="0" sldId="286"/>
-            <ac:inkMk id="8" creationId="{A68B4D75-9091-CD69-1BCE-968B40D83391}"/>
-          </ac:inkMkLst>
-        </pc:inkChg>
-        <pc:inkChg chg="add">
-          <ac:chgData name="Marcos Maillot" userId="fa14b39d-e966-4ebb-a436-4f96f84b9577" providerId="ADAL" clId="{2D40D906-DE93-44E5-B192-09259B1B360B}" dt="2025-11-26T00:58:57.189" v="186" actId="9405"/>
-          <ac:inkMkLst>
-            <pc:docMk/>
-            <pc:sldMk cId="0" sldId="286"/>
-            <ac:inkMk id="10" creationId="{AC0F1001-8A95-B5D8-8064-2F8CF7CC4F65}"/>
-          </ac:inkMkLst>
-        </pc:inkChg>
-        <pc:inkChg chg="add mod">
-          <ac:chgData name="Marcos Maillot" userId="fa14b39d-e966-4ebb-a436-4f96f84b9577" providerId="ADAL" clId="{2D40D906-DE93-44E5-B192-09259B1B360B}" dt="2025-11-26T00:59:33.472" v="217"/>
-          <ac:inkMkLst>
-            <pc:docMk/>
-            <pc:sldMk cId="0" sldId="286"/>
-            <ac:inkMk id="11" creationId="{66ED782A-941D-275A-93DC-A4756977A6B3}"/>
-          </ac:inkMkLst>
-        </pc:inkChg>
-        <pc:inkChg chg="add mod">
-          <ac:chgData name="Marcos Maillot" userId="fa14b39d-e966-4ebb-a436-4f96f84b9577" providerId="ADAL" clId="{2D40D906-DE93-44E5-B192-09259B1B360B}" dt="2025-11-26T00:59:19.355" v="208"/>
-          <ac:inkMkLst>
-            <pc:docMk/>
-            <pc:sldMk cId="0" sldId="286"/>
-            <ac:inkMk id="12" creationId="{B3D6B82E-51BE-264E-5733-F396CBA1A5A7}"/>
-          </ac:inkMkLst>
-        </pc:inkChg>
-        <pc:inkChg chg="add mod">
-          <ac:chgData name="Marcos Maillot" userId="fa14b39d-e966-4ebb-a436-4f96f84b9577" providerId="ADAL" clId="{2D40D906-DE93-44E5-B192-09259B1B360B}" dt="2025-11-26T00:59:33.472" v="217"/>
-          <ac:inkMkLst>
-            <pc:docMk/>
-            <pc:sldMk cId="0" sldId="286"/>
-            <ac:inkMk id="13" creationId="{9F3C6BE1-130E-CEC5-3514-083653170391}"/>
-          </ac:inkMkLst>
-        </pc:inkChg>
-        <pc:inkChg chg="add mod">
-          <ac:chgData name="Marcos Maillot" userId="fa14b39d-e966-4ebb-a436-4f96f84b9577" providerId="ADAL" clId="{2D40D906-DE93-44E5-B192-09259B1B360B}" dt="2025-11-26T00:59:33.472" v="217"/>
-          <ac:inkMkLst>
-            <pc:docMk/>
-            <pc:sldMk cId="0" sldId="286"/>
-            <ac:inkMk id="14" creationId="{1FC78BA3-9B32-3420-6B34-6945D87C06BB}"/>
-          </ac:inkMkLst>
-        </pc:inkChg>
-        <pc:inkChg chg="add">
-          <ac:chgData name="Marcos Maillot" userId="fa14b39d-e966-4ebb-a436-4f96f84b9577" providerId="ADAL" clId="{2D40D906-DE93-44E5-B192-09259B1B360B}" dt="2025-11-26T00:59:00.965" v="191" actId="9405"/>
-          <ac:inkMkLst>
-            <pc:docMk/>
-            <pc:sldMk cId="0" sldId="286"/>
-            <ac:inkMk id="15" creationId="{69FD23C7-EC55-92BC-043E-79ED9FEA22A7}"/>
-          </ac:inkMkLst>
-        </pc:inkChg>
-        <pc:inkChg chg="add">
-          <ac:chgData name="Marcos Maillot" userId="fa14b39d-e966-4ebb-a436-4f96f84b9577" providerId="ADAL" clId="{2D40D906-DE93-44E5-B192-09259B1B360B}" dt="2025-11-26T00:59:01.949" v="192" actId="9405"/>
-          <ac:inkMkLst>
-            <pc:docMk/>
-            <pc:sldMk cId="0" sldId="286"/>
-            <ac:inkMk id="16" creationId="{56C27375-E582-6794-9A9B-21EB3D9B8311}"/>
-          </ac:inkMkLst>
-        </pc:inkChg>
-        <pc:inkChg chg="add mod">
-          <ac:chgData name="Marcos Maillot" userId="fa14b39d-e966-4ebb-a436-4f96f84b9577" providerId="ADAL" clId="{2D40D906-DE93-44E5-B192-09259B1B360B}" dt="2025-11-26T00:59:23.338" v="210"/>
-          <ac:inkMkLst>
-            <pc:docMk/>
-            <pc:sldMk cId="0" sldId="286"/>
-            <ac:inkMk id="18" creationId="{635B863E-4789-2B07-5A8A-D360E8837DF7}"/>
-          </ac:inkMkLst>
-        </pc:inkChg>
-        <pc:inkChg chg="add mod">
-          <ac:chgData name="Marcos Maillot" userId="fa14b39d-e966-4ebb-a436-4f96f84b9577" providerId="ADAL" clId="{2D40D906-DE93-44E5-B192-09259B1B360B}" dt="2025-11-26T00:59:25.817" v="214"/>
-          <ac:inkMkLst>
-            <pc:docMk/>
-            <pc:sldMk cId="0" sldId="286"/>
-            <ac:inkMk id="19" creationId="{32109F71-A7F4-2421-F08E-D1FD772F5EB1}"/>
-          </ac:inkMkLst>
-        </pc:inkChg>
-        <pc:inkChg chg="add mod">
-          <ac:chgData name="Marcos Maillot" userId="fa14b39d-e966-4ebb-a436-4f96f84b9577" providerId="ADAL" clId="{2D40D906-DE93-44E5-B192-09259B1B360B}" dt="2025-11-26T00:59:19.355" v="208"/>
-          <ac:inkMkLst>
-            <pc:docMk/>
-            <pc:sldMk cId="0" sldId="286"/>
-            <ac:inkMk id="20" creationId="{4D016087-32A1-00A0-34D0-4DA6D2E2F72A}"/>
-          </ac:inkMkLst>
-        </pc:inkChg>
-        <pc:inkChg chg="add mod">
-          <ac:chgData name="Marcos Maillot" userId="fa14b39d-e966-4ebb-a436-4f96f84b9577" providerId="ADAL" clId="{2D40D906-DE93-44E5-B192-09259B1B360B}" dt="2025-11-26T00:59:23.338" v="210"/>
-          <ac:inkMkLst>
-            <pc:docMk/>
-            <pc:sldMk cId="0" sldId="286"/>
-            <ac:inkMk id="21" creationId="{56A1E6E2-15E2-442F-E7F7-3AF474171B4F}"/>
-          </ac:inkMkLst>
-        </pc:inkChg>
-        <pc:inkChg chg="add mod">
-          <ac:chgData name="Marcos Maillot" userId="fa14b39d-e966-4ebb-a436-4f96f84b9577" providerId="ADAL" clId="{2D40D906-DE93-44E5-B192-09259B1B360B}" dt="2025-11-26T00:59:14.899" v="202"/>
-          <ac:inkMkLst>
-            <pc:docMk/>
-            <pc:sldMk cId="0" sldId="286"/>
-            <ac:inkMk id="22" creationId="{862D596D-6AF0-B6FE-488D-2A336ED3DA8E}"/>
-          </ac:inkMkLst>
-        </pc:inkChg>
-        <pc:inkChg chg="add mod">
-          <ac:chgData name="Marcos Maillot" userId="fa14b39d-e966-4ebb-a436-4f96f84b9577" providerId="ADAL" clId="{2D40D906-DE93-44E5-B192-09259B1B360B}" dt="2025-11-26T00:59:25.817" v="214"/>
-          <ac:inkMkLst>
-            <pc:docMk/>
-            <pc:sldMk cId="0" sldId="286"/>
-            <ac:inkMk id="23" creationId="{FD3B7B2B-1895-5D18-7B6C-7C14AECEDF9B}"/>
-          </ac:inkMkLst>
-        </pc:inkChg>
-        <pc:inkChg chg="add mod">
-          <ac:chgData name="Marcos Maillot" userId="fa14b39d-e966-4ebb-a436-4f96f84b9577" providerId="ADAL" clId="{2D40D906-DE93-44E5-B192-09259B1B360B}" dt="2025-11-26T00:59:25.817" v="214"/>
-          <ac:inkMkLst>
-            <pc:docMk/>
-            <pc:sldMk cId="0" sldId="286"/>
-            <ac:inkMk id="24" creationId="{8BB4D3B1-D06E-AF55-7A2D-922E5D506E82}"/>
-          </ac:inkMkLst>
-        </pc:inkChg>
-        <pc:inkChg chg="add mod">
-          <ac:chgData name="Marcos Maillot" userId="fa14b39d-e966-4ebb-a436-4f96f84b9577" providerId="ADAL" clId="{2D40D906-DE93-44E5-B192-09259B1B360B}" dt="2025-11-26T00:59:25.817" v="214"/>
-          <ac:inkMkLst>
-            <pc:docMk/>
-            <pc:sldMk cId="0" sldId="286"/>
-            <ac:inkMk id="25" creationId="{74C552DF-0165-1400-D313-264F738CB534}"/>
-          </ac:inkMkLst>
-        </pc:inkChg>
-        <pc:inkChg chg="add mod">
-          <ac:chgData name="Marcos Maillot" userId="fa14b39d-e966-4ebb-a436-4f96f84b9577" providerId="ADAL" clId="{2D40D906-DE93-44E5-B192-09259B1B360B}" dt="2025-11-26T00:59:25.817" v="214"/>
-          <ac:inkMkLst>
-            <pc:docMk/>
-            <pc:sldMk cId="0" sldId="286"/>
-            <ac:inkMk id="27" creationId="{B605795E-F341-A80A-EBB7-E632D558F5EF}"/>
-          </ac:inkMkLst>
-        </pc:inkChg>
-        <pc:inkChg chg="add">
-          <ac:chgData name="Marcos Maillot" userId="fa14b39d-e966-4ebb-a436-4f96f84b9577" providerId="ADAL" clId="{2D40D906-DE93-44E5-B192-09259B1B360B}" dt="2025-11-26T00:59:15.446" v="204" actId="9405"/>
-          <ac:inkMkLst>
-            <pc:docMk/>
-            <pc:sldMk cId="0" sldId="286"/>
-            <ac:inkMk id="28" creationId="{853BE67F-D970-906B-19D3-9D2FFF0D9F8C}"/>
-          </ac:inkMkLst>
-        </pc:inkChg>
-        <pc:inkChg chg="add mod">
-          <ac:chgData name="Marcos Maillot" userId="fa14b39d-e966-4ebb-a436-4f96f84b9577" providerId="ADAL" clId="{2D40D906-DE93-44E5-B192-09259B1B360B}" dt="2025-11-26T00:59:33.472" v="217"/>
-          <ac:inkMkLst>
-            <pc:docMk/>
-            <pc:sldMk cId="0" sldId="286"/>
-            <ac:inkMk id="29" creationId="{C3CA14A9-4499-415A-9818-57F20308EC46}"/>
-          </ac:inkMkLst>
-        </pc:inkChg>
-        <pc:inkChg chg="add">
-          <ac:chgData name="Marcos Maillot" userId="fa14b39d-e966-4ebb-a436-4f96f84b9577" providerId="ADAL" clId="{2D40D906-DE93-44E5-B192-09259B1B360B}" dt="2025-11-26T00:59:17.752" v="206" actId="9405"/>
-          <ac:inkMkLst>
-            <pc:docMk/>
-            <pc:sldMk cId="0" sldId="286"/>
-            <ac:inkMk id="30" creationId="{327A5B4D-008C-BDB7-03CF-43A947D89351}"/>
-          </ac:inkMkLst>
-        </pc:inkChg>
-        <pc:inkChg chg="add">
-          <ac:chgData name="Marcos Maillot" userId="fa14b39d-e966-4ebb-a436-4f96f84b9577" providerId="ADAL" clId="{2D40D906-DE93-44E5-B192-09259B1B360B}" dt="2025-11-26T00:59:18.720" v="207" actId="9405"/>
-          <ac:inkMkLst>
-            <pc:docMk/>
-            <pc:sldMk cId="0" sldId="286"/>
-            <ac:inkMk id="31" creationId="{9BA36DDF-8F21-8C04-A601-FF092E9514C4}"/>
-          </ac:inkMkLst>
-        </pc:inkChg>
-        <pc:inkChg chg="add mod">
-          <ac:chgData name="Marcos Maillot" userId="fa14b39d-e966-4ebb-a436-4f96f84b9577" providerId="ADAL" clId="{2D40D906-DE93-44E5-B192-09259B1B360B}" dt="2025-11-26T00:59:25.817" v="214"/>
-          <ac:inkMkLst>
-            <pc:docMk/>
-            <pc:sldMk cId="0" sldId="286"/>
-            <ac:inkMk id="34" creationId="{0A7FA0F5-426B-E064-A8DE-30BE52423FB5}"/>
-          </ac:inkMkLst>
-        </pc:inkChg>
-        <pc:inkChg chg="add">
-          <ac:chgData name="Marcos Maillot" userId="fa14b39d-e966-4ebb-a436-4f96f84b9577" providerId="ADAL" clId="{2D40D906-DE93-44E5-B192-09259B1B360B}" dt="2025-11-26T00:59:23.369" v="211" actId="9405"/>
-          <ac:inkMkLst>
-            <pc:docMk/>
-            <pc:sldMk cId="0" sldId="286"/>
-            <ac:inkMk id="36" creationId="{B534A26C-58F6-1C19-6CEA-532A7DE3337D}"/>
-          </ac:inkMkLst>
-        </pc:inkChg>
-        <pc:inkChg chg="add mod">
-          <ac:chgData name="Marcos Maillot" userId="fa14b39d-e966-4ebb-a436-4f96f84b9577" providerId="ADAL" clId="{2D40D906-DE93-44E5-B192-09259B1B360B}" dt="2025-11-26T00:59:25.817" v="214"/>
-          <ac:inkMkLst>
-            <pc:docMk/>
-            <pc:sldMk cId="0" sldId="286"/>
-            <ac:inkMk id="37" creationId="{78243778-6024-00E6-EC18-5832FE2E22A1}"/>
-          </ac:inkMkLst>
-        </pc:inkChg>
-        <pc:inkChg chg="add mod">
-          <ac:chgData name="Marcos Maillot" userId="fa14b39d-e966-4ebb-a436-4f96f84b9577" providerId="ADAL" clId="{2D40D906-DE93-44E5-B192-09259B1B360B}" dt="2025-11-26T00:59:25.817" v="214"/>
-          <ac:inkMkLst>
-            <pc:docMk/>
-            <pc:sldMk cId="0" sldId="286"/>
-            <ac:inkMk id="38" creationId="{F22D697C-BFA2-7AD9-EED5-4FBFE2189204}"/>
-          </ac:inkMkLst>
-        </pc:inkChg>
-        <pc:inkChg chg="add mod">
-          <ac:chgData name="Marcos Maillot" userId="fa14b39d-e966-4ebb-a436-4f96f84b9577" providerId="ADAL" clId="{2D40D906-DE93-44E5-B192-09259B1B360B}" dt="2025-11-26T00:59:33.472" v="217"/>
-          <ac:inkMkLst>
-            <pc:docMk/>
-            <pc:sldMk cId="0" sldId="286"/>
-            <ac:inkMk id="40" creationId="{D7446FA2-C29B-50E6-398A-C03D5912B1D7}"/>
-          </ac:inkMkLst>
-        </pc:inkChg>
-        <pc:inkChg chg="add">
-          <ac:chgData name="Marcos Maillot" userId="fa14b39d-e966-4ebb-a436-4f96f84b9577" providerId="ADAL" clId="{2D40D906-DE93-44E5-B192-09259B1B360B}" dt="2025-11-26T00:59:32.579" v="216" actId="9405"/>
-          <ac:inkMkLst>
-            <pc:docMk/>
-            <pc:sldMk cId="0" sldId="286"/>
-            <ac:inkMk id="41" creationId="{03EBD833-9C2F-C80C-B79B-3BAA58884440}"/>
-          </ac:inkMkLst>
-        </pc:inkChg>
-      </pc:sldChg>
-      <pc:sldChg chg="addSp delSp modSp mod">
-        <pc:chgData name="Marcos Maillot" userId="fa14b39d-e966-4ebb-a436-4f96f84b9577" providerId="ADAL" clId="{2D40D906-DE93-44E5-B192-09259B1B360B}" dt="2025-11-26T00:58:33.146" v="177"/>
-        <pc:sldMkLst>
-          <pc:docMk/>
-          <pc:sldMk cId="2515468531" sldId="290"/>
-        </pc:sldMkLst>
-        <pc:grpChg chg="mod">
-          <ac:chgData name="Marcos Maillot" userId="fa14b39d-e966-4ebb-a436-4f96f84b9577" providerId="ADAL" clId="{2D40D906-DE93-44E5-B192-09259B1B360B}" dt="2025-11-26T00:58:33.146" v="177"/>
-          <ac:grpSpMkLst>
-            <pc:docMk/>
-            <pc:sldMk cId="2515468531" sldId="290"/>
-            <ac:grpSpMk id="14" creationId="{AF7F9655-0842-68BA-280E-0BDB7C8A3A74}"/>
-          </ac:grpSpMkLst>
-        </pc:grpChg>
-        <pc:inkChg chg="add">
-          <ac:chgData name="Marcos Maillot" userId="fa14b39d-e966-4ebb-a436-4f96f84b9577" providerId="ADAL" clId="{2D40D906-DE93-44E5-B192-09259B1B360B}" dt="2025-11-26T00:28:07.556" v="155" actId="9405"/>
-          <ac:inkMkLst>
-            <pc:docMk/>
-            <pc:sldMk cId="2515468531" sldId="290"/>
-            <ac:inkMk id="3" creationId="{5265AF4B-2294-BB38-F6AC-EC3B8891FDB2}"/>
-          </ac:inkMkLst>
-        </pc:inkChg>
-        <pc:inkChg chg="add">
-          <ac:chgData name="Marcos Maillot" userId="fa14b39d-e966-4ebb-a436-4f96f84b9577" providerId="ADAL" clId="{2D40D906-DE93-44E5-B192-09259B1B360B}" dt="2025-11-26T00:28:16.068" v="156" actId="9405"/>
-          <ac:inkMkLst>
-            <pc:docMk/>
-            <pc:sldMk cId="2515468531" sldId="290"/>
-            <ac:inkMk id="4" creationId="{67B58939-3294-BD56-C1F1-32C0C1CE4A69}"/>
-          </ac:inkMkLst>
-        </pc:inkChg>
-        <pc:inkChg chg="add mod">
-          <ac:chgData name="Marcos Maillot" userId="fa14b39d-e966-4ebb-a436-4f96f84b9577" providerId="ADAL" clId="{2D40D906-DE93-44E5-B192-09259B1B360B}" dt="2025-11-26T00:58:33.146" v="177"/>
-          <ac:inkMkLst>
-            <pc:docMk/>
-            <pc:sldMk cId="2515468531" sldId="290"/>
-            <ac:inkMk id="5" creationId="{748F5668-5A3B-DF0E-6950-A6F84C493D07}"/>
-          </ac:inkMkLst>
-        </pc:inkChg>
-        <pc:inkChg chg="add mod">
-          <ac:chgData name="Marcos Maillot" userId="fa14b39d-e966-4ebb-a436-4f96f84b9577" providerId="ADAL" clId="{2D40D906-DE93-44E5-B192-09259B1B360B}" dt="2025-11-26T00:58:33.146" v="177"/>
-          <ac:inkMkLst>
-            <pc:docMk/>
-            <pc:sldMk cId="2515468531" sldId="290"/>
-            <ac:inkMk id="6" creationId="{696478D7-3A6F-8913-A3F7-A32E73FCA0A9}"/>
-          </ac:inkMkLst>
-        </pc:inkChg>
-        <pc:inkChg chg="add mod">
-          <ac:chgData name="Marcos Maillot" userId="fa14b39d-e966-4ebb-a436-4f96f84b9577" providerId="ADAL" clId="{2D40D906-DE93-44E5-B192-09259B1B360B}" dt="2025-11-26T00:58:33.146" v="177"/>
-          <ac:inkMkLst>
-            <pc:docMk/>
-            <pc:sldMk cId="2515468531" sldId="290"/>
-            <ac:inkMk id="7" creationId="{EE72F000-EB39-A131-D8F5-5D4DA69E9D3A}"/>
-          </ac:inkMkLst>
-        </pc:inkChg>
-        <pc:inkChg chg="add mod">
-          <ac:chgData name="Marcos Maillot" userId="fa14b39d-e966-4ebb-a436-4f96f84b9577" providerId="ADAL" clId="{2D40D906-DE93-44E5-B192-09259B1B360B}" dt="2025-11-26T00:58:33.146" v="177"/>
-          <ac:inkMkLst>
-            <pc:docMk/>
-            <pc:sldMk cId="2515468531" sldId="290"/>
-            <ac:inkMk id="8" creationId="{C47C07A3-0540-80B9-461E-26384F6D0328}"/>
-          </ac:inkMkLst>
-        </pc:inkChg>
-        <pc:inkChg chg="add mod">
-          <ac:chgData name="Marcos Maillot" userId="fa14b39d-e966-4ebb-a436-4f96f84b9577" providerId="ADAL" clId="{2D40D906-DE93-44E5-B192-09259B1B360B}" dt="2025-11-26T00:58:33.146" v="177"/>
-          <ac:inkMkLst>
-            <pc:docMk/>
-            <pc:sldMk cId="2515468531" sldId="290"/>
-            <ac:inkMk id="9" creationId="{7EC5E78A-F82B-DCCD-9ABB-B0E9C4D8B6A3}"/>
-          </ac:inkMkLst>
-        </pc:inkChg>
-        <pc:inkChg chg="add mod">
-          <ac:chgData name="Marcos Maillot" userId="fa14b39d-e966-4ebb-a436-4f96f84b9577" providerId="ADAL" clId="{2D40D906-DE93-44E5-B192-09259B1B360B}" dt="2025-11-26T00:58:33.146" v="177"/>
-          <ac:inkMkLst>
-            <pc:docMk/>
-            <pc:sldMk cId="2515468531" sldId="290"/>
-            <ac:inkMk id="10" creationId="{9A10811A-8FAD-BE6D-2FD7-6D4594DCE3FD}"/>
-          </ac:inkMkLst>
-        </pc:inkChg>
-        <pc:inkChg chg="add mod">
-          <ac:chgData name="Marcos Maillot" userId="fa14b39d-e966-4ebb-a436-4f96f84b9577" providerId="ADAL" clId="{2D40D906-DE93-44E5-B192-09259B1B360B}" dt="2025-11-26T00:58:33.146" v="177"/>
-          <ac:inkMkLst>
-            <pc:docMk/>
-            <pc:sldMk cId="2515468531" sldId="290"/>
-            <ac:inkMk id="11" creationId="{BD9FE9D8-7F6A-9A12-03CF-FF463AF3A7A7}"/>
-          </ac:inkMkLst>
-        </pc:inkChg>
-        <pc:inkChg chg="add mod">
-          <ac:chgData name="Marcos Maillot" userId="fa14b39d-e966-4ebb-a436-4f96f84b9577" providerId="ADAL" clId="{2D40D906-DE93-44E5-B192-09259B1B360B}" dt="2025-11-26T00:58:33.146" v="177"/>
-          <ac:inkMkLst>
-            <pc:docMk/>
-            <pc:sldMk cId="2515468531" sldId="290"/>
-            <ac:inkMk id="12" creationId="{F89F23C6-223F-1266-BF3F-2552A2A095CF}"/>
-          </ac:inkMkLst>
-        </pc:inkChg>
-        <pc:inkChg chg="add mod">
-          <ac:chgData name="Marcos Maillot" userId="fa14b39d-e966-4ebb-a436-4f96f84b9577" providerId="ADAL" clId="{2D40D906-DE93-44E5-B192-09259B1B360B}" dt="2025-11-26T00:58:33.146" v="177"/>
-          <ac:inkMkLst>
-            <pc:docMk/>
-            <pc:sldMk cId="2515468531" sldId="290"/>
-            <ac:inkMk id="13" creationId="{6D151D73-78F2-07FE-456E-081A5C87771D}"/>
-          </ac:inkMkLst>
-        </pc:inkChg>
-        <pc:inkChg chg="del">
-          <ac:chgData name="Marcos Maillot" userId="fa14b39d-e966-4ebb-a436-4f96f84b9577" providerId="ADAL" clId="{2D40D906-DE93-44E5-B192-09259B1B360B}" dt="2025-11-25T19:47:21.935" v="5" actId="478"/>
-          <ac:inkMkLst>
-            <pc:docMk/>
-            <pc:sldMk cId="2515468531" sldId="290"/>
-            <ac:inkMk id="32" creationId="{F86F9C7D-34C0-E6B9-FB77-A57B4D28DF75}"/>
-          </ac:inkMkLst>
-        </pc:inkChg>
-        <pc:inkChg chg="del">
-          <ac:chgData name="Marcos Maillot" userId="fa14b39d-e966-4ebb-a436-4f96f84b9577" providerId="ADAL" clId="{2D40D906-DE93-44E5-B192-09259B1B360B}" dt="2025-11-25T19:47:19.194" v="2" actId="478"/>
-          <ac:inkMkLst>
-            <pc:docMk/>
-            <pc:sldMk cId="2515468531" sldId="290"/>
-            <ac:inkMk id="34" creationId="{EF8CA6B9-CA97-16BB-CCB1-E341210A51A2}"/>
-          </ac:inkMkLst>
-        </pc:inkChg>
-        <pc:inkChg chg="del">
-          <ac:chgData name="Marcos Maillot" userId="fa14b39d-e966-4ebb-a436-4f96f84b9577" providerId="ADAL" clId="{2D40D906-DE93-44E5-B192-09259B1B360B}" dt="2025-11-25T19:47:21.146" v="4" actId="478"/>
-          <ac:inkMkLst>
-            <pc:docMk/>
-            <pc:sldMk cId="2515468531" sldId="290"/>
-            <ac:inkMk id="38" creationId="{57A2C929-7F91-F2E4-96CF-772160773EEC}"/>
-          </ac:inkMkLst>
-        </pc:inkChg>
-        <pc:inkChg chg="del">
-          <ac:chgData name="Marcos Maillot" userId="fa14b39d-e966-4ebb-a436-4f96f84b9577" providerId="ADAL" clId="{2D40D906-DE93-44E5-B192-09259B1B360B}" dt="2025-11-25T19:47:17.969" v="1" actId="478"/>
-          <ac:inkMkLst>
-            <pc:docMk/>
-            <pc:sldMk cId="2515468531" sldId="290"/>
-            <ac:inkMk id="44" creationId="{A751ABB3-DE01-390D-D9FC-2A9143389971}"/>
-          </ac:inkMkLst>
-        </pc:inkChg>
-        <pc:inkChg chg="del">
-          <ac:chgData name="Marcos Maillot" userId="fa14b39d-e966-4ebb-a436-4f96f84b9577" providerId="ADAL" clId="{2D40D906-DE93-44E5-B192-09259B1B360B}" dt="2025-11-25T19:47:19.976" v="3" actId="478"/>
-          <ac:inkMkLst>
-            <pc:docMk/>
-            <pc:sldMk cId="2515468531" sldId="290"/>
-            <ac:inkMk id="47" creationId="{4F3AE93E-2A00-420A-A624-473C689FB60B}"/>
-          </ac:inkMkLst>
-        </pc:inkChg>
-      </pc:sldChg>
-      <pc:sldChg chg="del">
-        <pc:chgData name="Marcos Maillot" userId="fa14b39d-e966-4ebb-a436-4f96f84b9577" providerId="ADAL" clId="{2D40D906-DE93-44E5-B192-09259B1B360B}" dt="2025-11-25T19:46:55.054" v="0" actId="47"/>
-        <pc:sldMkLst>
-          <pc:docMk/>
-          <pc:sldMk cId="3552047750" sldId="297"/>
-        </pc:sldMkLst>
-      </pc:sldChg>
-      <pc:sldChg chg="addSp delSp modSp new mod">
-        <pc:chgData name="Marcos Maillot" userId="fa14b39d-e966-4ebb-a436-4f96f84b9577" providerId="ADAL" clId="{2D40D906-DE93-44E5-B192-09259B1B360B}" dt="2025-11-26T00:28:35.766" v="167"/>
-        <pc:sldMkLst>
-          <pc:docMk/>
-          <pc:sldMk cId="4029029847" sldId="297"/>
-        </pc:sldMkLst>
-        <pc:grpChg chg="del mod">
-          <ac:chgData name="Marcos Maillot" userId="fa14b39d-e966-4ebb-a436-4f96f84b9577" providerId="ADAL" clId="{2D40D906-DE93-44E5-B192-09259B1B360B}" dt="2025-11-26T00:25:11.149" v="86"/>
-          <ac:grpSpMkLst>
-            <pc:docMk/>
-            <pc:sldMk cId="4029029847" sldId="297"/>
-            <ac:grpSpMk id="20" creationId="{01BB4B54-CC8F-9234-35DE-0E4AD80C058A}"/>
-          </ac:grpSpMkLst>
-        </pc:grpChg>
-        <pc:grpChg chg="del mod">
-          <ac:chgData name="Marcos Maillot" userId="fa14b39d-e966-4ebb-a436-4f96f84b9577" providerId="ADAL" clId="{2D40D906-DE93-44E5-B192-09259B1B360B}" dt="2025-11-26T00:28:26.203" v="159"/>
-          <ac:grpSpMkLst>
-            <pc:docMk/>
-            <pc:sldMk cId="4029029847" sldId="297"/>
-            <ac:grpSpMk id="23" creationId="{AD0B405D-0849-E6D5-A0A7-10A710FF20F0}"/>
-          </ac:grpSpMkLst>
-        </pc:grpChg>
-        <pc:grpChg chg="del mod">
-          <ac:chgData name="Marcos Maillot" userId="fa14b39d-e966-4ebb-a436-4f96f84b9577" providerId="ADAL" clId="{2D40D906-DE93-44E5-B192-09259B1B360B}" dt="2025-11-26T00:28:32.254" v="163"/>
-          <ac:grpSpMkLst>
-            <pc:docMk/>
-            <pc:sldMk cId="4029029847" sldId="297"/>
-            <ac:grpSpMk id="30" creationId="{4251BA1E-B9AC-B2CB-2682-288A0F6879AB}"/>
-          </ac:grpSpMkLst>
-        </pc:grpChg>
-        <pc:grpChg chg="del mod">
-          <ac:chgData name="Marcos Maillot" userId="fa14b39d-e966-4ebb-a436-4f96f84b9577" providerId="ADAL" clId="{2D40D906-DE93-44E5-B192-09259B1B360B}" dt="2025-11-26T00:25:22.931" v="100"/>
-          <ac:grpSpMkLst>
-            <pc:docMk/>
-            <pc:sldMk cId="4029029847" sldId="297"/>
-            <ac:grpSpMk id="31" creationId="{03AA7BEA-8C20-8A66-1405-8184C7C975E1}"/>
-          </ac:grpSpMkLst>
-        </pc:grpChg>
-        <pc:grpChg chg="del mod">
-          <ac:chgData name="Marcos Maillot" userId="fa14b39d-e966-4ebb-a436-4f96f84b9577" providerId="ADAL" clId="{2D40D906-DE93-44E5-B192-09259B1B360B}" dt="2025-11-26T00:25:53.788" v="148"/>
-          <ac:grpSpMkLst>
-            <pc:docMk/>
-            <pc:sldMk cId="4029029847" sldId="297"/>
-            <ac:grpSpMk id="38" creationId="{551EC61B-FDC8-1ECE-39CF-7CD45210DC1B}"/>
-          </ac:grpSpMkLst>
-        </pc:grpChg>
-        <pc:grpChg chg="del mod">
-          <ac:chgData name="Marcos Maillot" userId="fa14b39d-e966-4ebb-a436-4f96f84b9577" providerId="ADAL" clId="{2D40D906-DE93-44E5-B192-09259B1B360B}" dt="2025-11-26T00:28:32.254" v="163"/>
-          <ac:grpSpMkLst>
-            <pc:docMk/>
-            <pc:sldMk cId="4029029847" sldId="297"/>
-            <ac:grpSpMk id="39" creationId="{69C583B8-34F6-2706-39CF-5EE034B00779}"/>
-          </ac:grpSpMkLst>
-        </pc:grpChg>
-        <pc:grpChg chg="del mod">
-          <ac:chgData name="Marcos Maillot" userId="fa14b39d-e966-4ebb-a436-4f96f84b9577" providerId="ADAL" clId="{2D40D906-DE93-44E5-B192-09259B1B360B}" dt="2025-11-26T00:25:58.792" v="153"/>
-          <ac:grpSpMkLst>
-            <pc:docMk/>
-            <pc:sldMk cId="4029029847" sldId="297"/>
-            <ac:grpSpMk id="56" creationId="{4FD55558-601E-F85E-469E-8226241B4CAD}"/>
-          </ac:grpSpMkLst>
-        </pc:grpChg>
-        <pc:grpChg chg="mod">
-          <ac:chgData name="Marcos Maillot" userId="fa14b39d-e966-4ebb-a436-4f96f84b9577" providerId="ADAL" clId="{2D40D906-DE93-44E5-B192-09259B1B360B}" dt="2025-11-26T00:25:31.805" v="117"/>
-          <ac:grpSpMkLst>
-            <pc:docMk/>
-            <pc:sldMk cId="4029029847" sldId="297"/>
-            <ac:grpSpMk id="57" creationId="{B21759D2-F1C8-39B9-F47F-B3C578953FB4}"/>
-          </ac:grpSpMkLst>
-        </pc:grpChg>
-        <pc:grpChg chg="del mod">
-          <ac:chgData name="Marcos Maillot" userId="fa14b39d-e966-4ebb-a436-4f96f84b9577" providerId="ADAL" clId="{2D40D906-DE93-44E5-B192-09259B1B360B}" dt="2025-11-26T00:25:58.792" v="153"/>
-          <ac:grpSpMkLst>
-            <pc:docMk/>
-            <pc:sldMk cId="4029029847" sldId="297"/>
-            <ac:grpSpMk id="58" creationId="{A6DF8229-09C3-6E5F-0FEA-F917D9B45B83}"/>
-          </ac:grpSpMkLst>
-        </pc:grpChg>
-        <pc:grpChg chg="mod">
-          <ac:chgData name="Marcos Maillot" userId="fa14b39d-e966-4ebb-a436-4f96f84b9577" providerId="ADAL" clId="{2D40D906-DE93-44E5-B192-09259B1B360B}" dt="2025-11-26T00:25:31.805" v="117"/>
-          <ac:grpSpMkLst>
-            <pc:docMk/>
-            <pc:sldMk cId="4029029847" sldId="297"/>
-            <ac:grpSpMk id="59" creationId="{EF295D2B-9153-8C81-C561-48032087E1B3}"/>
-          </ac:grpSpMkLst>
-        </pc:grpChg>
-        <pc:grpChg chg="del mod">
-          <ac:chgData name="Marcos Maillot" userId="fa14b39d-e966-4ebb-a436-4f96f84b9577" providerId="ADAL" clId="{2D40D906-DE93-44E5-B192-09259B1B360B}" dt="2025-11-26T00:25:36.931" v="123"/>
-          <ac:grpSpMkLst>
-            <pc:docMk/>
-            <pc:sldMk cId="4029029847" sldId="297"/>
-            <ac:grpSpMk id="65" creationId="{96BC15D0-2F88-F650-2FBF-2BF7CC24179C}"/>
-          </ac:grpSpMkLst>
-        </pc:grpChg>
-        <pc:grpChg chg="del mod">
-          <ac:chgData name="Marcos Maillot" userId="fa14b39d-e966-4ebb-a436-4f96f84b9577" providerId="ADAL" clId="{2D40D906-DE93-44E5-B192-09259B1B360B}" dt="2025-11-26T00:25:58.792" v="153"/>
-          <ac:grpSpMkLst>
-            <pc:docMk/>
-            <pc:sldMk cId="4029029847" sldId="297"/>
-            <ac:grpSpMk id="66" creationId="{AF84B259-5134-4258-57C9-EC4E1DC34A70}"/>
-          </ac:grpSpMkLst>
-        </pc:grpChg>
-        <pc:grpChg chg="mod">
-          <ac:chgData name="Marcos Maillot" userId="fa14b39d-e966-4ebb-a436-4f96f84b9577" providerId="ADAL" clId="{2D40D906-DE93-44E5-B192-09259B1B360B}" dt="2025-11-26T00:25:46.786" v="133"/>
-          <ac:grpSpMkLst>
-            <pc:docMk/>
-            <pc:sldMk cId="4029029847" sldId="297"/>
-            <ac:grpSpMk id="76" creationId="{42D71233-D107-9573-91D0-A7816619D034}"/>
-          </ac:grpSpMkLst>
-        </pc:grpChg>
-        <pc:grpChg chg="mod">
-          <ac:chgData name="Marcos Maillot" userId="fa14b39d-e966-4ebb-a436-4f96f84b9577" providerId="ADAL" clId="{2D40D906-DE93-44E5-B192-09259B1B360B}" dt="2025-11-26T00:25:52.369" v="146"/>
-          <ac:grpSpMkLst>
-            <pc:docMk/>
-            <pc:sldMk cId="4029029847" sldId="297"/>
-            <ac:grpSpMk id="89" creationId="{1E055F2D-01B3-1897-5AD0-EAF1A614C930}"/>
-          </ac:grpSpMkLst>
-        </pc:grpChg>
-        <pc:grpChg chg="del mod">
-          <ac:chgData name="Marcos Maillot" userId="fa14b39d-e966-4ebb-a436-4f96f84b9577" providerId="ADAL" clId="{2D40D906-DE93-44E5-B192-09259B1B360B}" dt="2025-11-26T00:28:32.254" v="163"/>
-          <ac:grpSpMkLst>
-            <pc:docMk/>
-            <pc:sldMk cId="4029029847" sldId="297"/>
-            <ac:grpSpMk id="91" creationId="{84959EA6-E62D-5489-DA52-463F34F57FFD}"/>
-          </ac:grpSpMkLst>
-        </pc:grpChg>
-        <pc:grpChg chg="mod">
-          <ac:chgData name="Marcos Maillot" userId="fa14b39d-e966-4ebb-a436-4f96f84b9577" providerId="ADAL" clId="{2D40D906-DE93-44E5-B192-09259B1B360B}" dt="2025-11-26T00:25:58.792" v="153"/>
-          <ac:grpSpMkLst>
-            <pc:docMk/>
-            <pc:sldMk cId="4029029847" sldId="297"/>
-            <ac:grpSpMk id="96" creationId="{22438974-89D3-B466-A051-49838A59FBE1}"/>
-          </ac:grpSpMkLst>
-        </pc:grpChg>
-        <pc:grpChg chg="mod">
-          <ac:chgData name="Marcos Maillot" userId="fa14b39d-e966-4ebb-a436-4f96f84b9577" providerId="ADAL" clId="{2D40D906-DE93-44E5-B192-09259B1B360B}" dt="2025-11-26T00:25:58.792" v="153"/>
-          <ac:grpSpMkLst>
-            <pc:docMk/>
-            <pc:sldMk cId="4029029847" sldId="297"/>
-            <ac:grpSpMk id="97" creationId="{87842CA8-409B-32E6-92A0-6F5ACF0FB258}"/>
-          </ac:grpSpMkLst>
-        </pc:grpChg>
-        <pc:grpChg chg="mod">
-          <ac:chgData name="Marcos Maillot" userId="fa14b39d-e966-4ebb-a436-4f96f84b9577" providerId="ADAL" clId="{2D40D906-DE93-44E5-B192-09259B1B360B}" dt="2025-11-26T00:25:58.792" v="153"/>
-          <ac:grpSpMkLst>
-            <pc:docMk/>
-            <pc:sldMk cId="4029029847" sldId="297"/>
-            <ac:grpSpMk id="98" creationId="{E11F857D-C3F6-96DA-0427-6275F0DC32D3}"/>
-          </ac:grpSpMkLst>
-        </pc:grpChg>
-        <pc:grpChg chg="del mod">
-          <ac:chgData name="Marcos Maillot" userId="fa14b39d-e966-4ebb-a436-4f96f84b9577" providerId="ADAL" clId="{2D40D906-DE93-44E5-B192-09259B1B360B}" dt="2025-11-26T00:28:29.351" v="161"/>
-          <ac:grpSpMkLst>
-            <pc:docMk/>
-            <pc:sldMk cId="4029029847" sldId="297"/>
-            <ac:grpSpMk id="102" creationId="{7F08B012-BB9A-95B9-296B-ECA9FFAECC8B}"/>
-          </ac:grpSpMkLst>
-        </pc:grpChg>
-        <pc:grpChg chg="del mod">
-          <ac:chgData name="Marcos Maillot" userId="fa14b39d-e966-4ebb-a436-4f96f84b9577" providerId="ADAL" clId="{2D40D906-DE93-44E5-B192-09259B1B360B}" dt="2025-11-26T00:28:35.766" v="167"/>
-          <ac:grpSpMkLst>
-            <pc:docMk/>
-            <pc:sldMk cId="4029029847" sldId="297"/>
-            <ac:grpSpMk id="104" creationId="{50DE2C40-D96B-B79C-F94C-2F57D594D514}"/>
-          </ac:grpSpMkLst>
-        </pc:grpChg>
-        <pc:grpChg chg="del mod">
-          <ac:chgData name="Marcos Maillot" userId="fa14b39d-e966-4ebb-a436-4f96f84b9577" providerId="ADAL" clId="{2D40D906-DE93-44E5-B192-09259B1B360B}" dt="2025-11-26T00:28:35.766" v="167"/>
-          <ac:grpSpMkLst>
-            <pc:docMk/>
-            <pc:sldMk cId="4029029847" sldId="297"/>
-            <ac:grpSpMk id="106" creationId="{F32C7C84-2529-3F84-3124-62F65E5B9BED}"/>
-          </ac:grpSpMkLst>
-        </pc:grpChg>
-        <pc:grpChg chg="mod">
-          <ac:chgData name="Marcos Maillot" userId="fa14b39d-e966-4ebb-a436-4f96f84b9577" providerId="ADAL" clId="{2D40D906-DE93-44E5-B192-09259B1B360B}" dt="2025-11-26T00:28:35.766" v="167"/>
-          <ac:grpSpMkLst>
-            <pc:docMk/>
-            <pc:sldMk cId="4029029847" sldId="297"/>
-            <ac:grpSpMk id="110" creationId="{1A0D10F6-B6D4-C75D-273F-334F00ECEF79}"/>
-          </ac:grpSpMkLst>
-        </pc:grpChg>
-        <pc:grpChg chg="mod">
-          <ac:chgData name="Marcos Maillot" userId="fa14b39d-e966-4ebb-a436-4f96f84b9577" providerId="ADAL" clId="{2D40D906-DE93-44E5-B192-09259B1B360B}" dt="2025-11-26T00:28:35.766" v="167"/>
-          <ac:grpSpMkLst>
-            <pc:docMk/>
-            <pc:sldMk cId="4029029847" sldId="297"/>
-            <ac:grpSpMk id="111" creationId="{BB20B92A-9E5C-116F-A6B4-4858B566C115}"/>
-          </ac:grpSpMkLst>
-        </pc:grpChg>
-        <pc:inkChg chg="add mod">
-          <ac:chgData name="Marcos Maillot" userId="fa14b39d-e966-4ebb-a436-4f96f84b9577" providerId="ADAL" clId="{2D40D906-DE93-44E5-B192-09259B1B360B}" dt="2025-11-26T00:28:29.351" v="161"/>
-          <ac:inkMkLst>
-            <pc:docMk/>
-            <pc:sldMk cId="4029029847" sldId="297"/>
-            <ac:inkMk id="3" creationId="{83E1342F-CBC3-769C-E73E-5CBA4188168D}"/>
-          </ac:inkMkLst>
-        </pc:inkChg>
-        <pc:inkChg chg="add mod">
-          <ac:chgData name="Marcos Maillot" userId="fa14b39d-e966-4ebb-a436-4f96f84b9577" providerId="ADAL" clId="{2D40D906-DE93-44E5-B192-09259B1B360B}" dt="2025-11-26T00:28:29.351" v="161"/>
-          <ac:inkMkLst>
-            <pc:docMk/>
-            <pc:sldMk cId="4029029847" sldId="297"/>
-            <ac:inkMk id="4" creationId="{DAFA7DD7-0909-AD49-4244-908F07C7FC08}"/>
-          </ac:inkMkLst>
-        </pc:inkChg>
-        <pc:inkChg chg="add">
-          <ac:chgData name="Marcos Maillot" userId="fa14b39d-e966-4ebb-a436-4f96f84b9577" providerId="ADAL" clId="{2D40D906-DE93-44E5-B192-09259B1B360B}" dt="2025-11-26T00:25:04.673" v="68" actId="9405"/>
-          <ac:inkMkLst>
-            <pc:docMk/>
-            <pc:sldMk cId="4029029847" sldId="297"/>
-            <ac:inkMk id="5" creationId="{3E564D4E-1BD1-8D15-2BF7-24C7348F48D3}"/>
-          </ac:inkMkLst>
-        </pc:inkChg>
-        <pc:inkChg chg="add">
-          <ac:chgData name="Marcos Maillot" userId="fa14b39d-e966-4ebb-a436-4f96f84b9577" providerId="ADAL" clId="{2D40D906-DE93-44E5-B192-09259B1B360B}" dt="2025-11-26T00:25:05.067" v="69" actId="9405"/>
-          <ac:inkMkLst>
-            <pc:docMk/>
-            <pc:sldMk cId="4029029847" sldId="297"/>
-            <ac:inkMk id="6" creationId="{90F0C947-602F-EE14-BB03-F631146E2AD0}"/>
-          </ac:inkMkLst>
-        </pc:inkChg>
-        <pc:inkChg chg="add">
-          <ac:chgData name="Marcos Maillot" userId="fa14b39d-e966-4ebb-a436-4f96f84b9577" providerId="ADAL" clId="{2D40D906-DE93-44E5-B192-09259B1B360B}" dt="2025-11-26T00:25:05.318" v="70" actId="9405"/>
-          <ac:inkMkLst>
-            <pc:docMk/>
-            <pc:sldMk cId="4029029847" sldId="297"/>
-            <ac:inkMk id="7" creationId="{7D76E328-4C61-0EB6-D169-CBCC557F9A0E}"/>
-          </ac:inkMkLst>
-        </pc:inkChg>
-        <pc:inkChg chg="add mod">
-          <ac:chgData name="Marcos Maillot" userId="fa14b39d-e966-4ebb-a436-4f96f84b9577" providerId="ADAL" clId="{2D40D906-DE93-44E5-B192-09259B1B360B}" dt="2025-11-26T00:28:29.351" v="161"/>
-          <ac:inkMkLst>
-            <pc:docMk/>
-            <pc:sldMk cId="4029029847" sldId="297"/>
-            <ac:inkMk id="8" creationId="{CD6CD978-A1BB-C8A5-338C-24DBFAC68B7C}"/>
-          </ac:inkMkLst>
-        </pc:inkChg>
-        <pc:inkChg chg="add">
-          <ac:chgData name="Marcos Maillot" userId="fa14b39d-e966-4ebb-a436-4f96f84b9577" providerId="ADAL" clId="{2D40D906-DE93-44E5-B192-09259B1B360B}" dt="2025-11-26T00:25:05.930" v="72" actId="9405"/>
-          <ac:inkMkLst>
-            <pc:docMk/>
-            <pc:sldMk cId="4029029847" sldId="297"/>
-            <ac:inkMk id="9" creationId="{3117C3C3-74A6-C99D-0F5D-6989A6E1A304}"/>
-          </ac:inkMkLst>
-        </pc:inkChg>
-        <pc:inkChg chg="add mod">
-          <ac:chgData name="Marcos Maillot" userId="fa14b39d-e966-4ebb-a436-4f96f84b9577" providerId="ADAL" clId="{2D40D906-DE93-44E5-B192-09259B1B360B}" dt="2025-11-26T00:28:35.766" v="167"/>
-          <ac:inkMkLst>
-            <pc:docMk/>
-            <pc:sldMk cId="4029029847" sldId="297"/>
-            <ac:inkMk id="10" creationId="{C3D87083-8A74-D451-7AA0-3C50864B343D}"/>
-          </ac:inkMkLst>
-        </pc:inkChg>
-        <pc:inkChg chg="add">
-          <ac:chgData name="Marcos Maillot" userId="fa14b39d-e966-4ebb-a436-4f96f84b9577" providerId="ADAL" clId="{2D40D906-DE93-44E5-B192-09259B1B360B}" dt="2025-11-26T00:25:06.385" v="74" actId="9405"/>
-          <ac:inkMkLst>
-            <pc:docMk/>
-            <pc:sldMk cId="4029029847" sldId="297"/>
-            <ac:inkMk id="11" creationId="{41430A4A-C15D-0CDA-41BA-6D8AB91948ED}"/>
-          </ac:inkMkLst>
-        </pc:inkChg>
-        <pc:inkChg chg="add mod">
-          <ac:chgData name="Marcos Maillot" userId="fa14b39d-e966-4ebb-a436-4f96f84b9577" providerId="ADAL" clId="{2D40D906-DE93-44E5-B192-09259B1B360B}" dt="2025-11-26T00:28:26.203" v="159"/>
-          <ac:inkMkLst>
-            <pc:docMk/>
-            <pc:sldMk cId="4029029847" sldId="297"/>
-            <ac:inkMk id="12" creationId="{E0F3122D-E686-F619-D20A-34429F4701ED}"/>
-          </ac:inkMkLst>
-        </pc:inkChg>
-        <pc:inkChg chg="add mod">
-          <ac:chgData name="Marcos Maillot" userId="fa14b39d-e966-4ebb-a436-4f96f84b9577" providerId="ADAL" clId="{2D40D906-DE93-44E5-B192-09259B1B360B}" dt="2025-11-26T00:28:35.766" v="167"/>
-          <ac:inkMkLst>
-            <pc:docMk/>
-            <pc:sldMk cId="4029029847" sldId="297"/>
-            <ac:inkMk id="13" creationId="{9F3D0BD5-2726-F3D0-16F3-F43AFF2E0AC7}"/>
-          </ac:inkMkLst>
-        </pc:inkChg>
-        <pc:inkChg chg="add mod">
-          <ac:chgData name="Marcos Maillot" userId="fa14b39d-e966-4ebb-a436-4f96f84b9577" providerId="ADAL" clId="{2D40D906-DE93-44E5-B192-09259B1B360B}" dt="2025-11-26T00:28:29.351" v="161"/>
-          <ac:inkMkLst>
-            <pc:docMk/>
-            <pc:sldMk cId="4029029847" sldId="297"/>
-            <ac:inkMk id="14" creationId="{4B3970F2-D633-54D2-2178-BC560052ADD0}"/>
-          </ac:inkMkLst>
-        </pc:inkChg>
-        <pc:inkChg chg="add mod">
-          <ac:chgData name="Marcos Maillot" userId="fa14b39d-e966-4ebb-a436-4f96f84b9577" providerId="ADAL" clId="{2D40D906-DE93-44E5-B192-09259B1B360B}" dt="2025-11-26T00:28:29.351" v="161"/>
-          <ac:inkMkLst>
-            <pc:docMk/>
-            <pc:sldMk cId="4029029847" sldId="297"/>
-            <ac:inkMk id="15" creationId="{3CD3F838-EECC-CE4C-E379-A50CE0A0C500}"/>
-          </ac:inkMkLst>
-        </pc:inkChg>
-        <pc:inkChg chg="add">
-          <ac:chgData name="Marcos Maillot" userId="fa14b39d-e966-4ebb-a436-4f96f84b9577" providerId="ADAL" clId="{2D40D906-DE93-44E5-B192-09259B1B360B}" dt="2025-11-26T00:25:07.819" v="79" actId="9405"/>
-          <ac:inkMkLst>
-            <pc:docMk/>
-            <pc:sldMk cId="4029029847" sldId="297"/>
-            <ac:inkMk id="16" creationId="{464CFDA7-33B5-5F79-7C92-C204415CBA94}"/>
-          </ac:inkMkLst>
-        </pc:inkChg>
-        <pc:inkChg chg="add mod">
-          <ac:chgData name="Marcos Maillot" userId="fa14b39d-e966-4ebb-a436-4f96f84b9577" providerId="ADAL" clId="{2D40D906-DE93-44E5-B192-09259B1B360B}" dt="2025-11-26T00:28:29.351" v="161"/>
-          <ac:inkMkLst>
-            <pc:docMk/>
-            <pc:sldMk cId="4029029847" sldId="297"/>
-            <ac:inkMk id="17" creationId="{E2AC7080-79BB-233B-05D0-61C255969D4E}"/>
-          </ac:inkMkLst>
-        </pc:inkChg>
-        <pc:inkChg chg="add">
-          <ac:chgData name="Marcos Maillot" userId="fa14b39d-e966-4ebb-a436-4f96f84b9577" providerId="ADAL" clId="{2D40D906-DE93-44E5-B192-09259B1B360B}" dt="2025-11-26T00:25:08.262" v="81" actId="9405"/>
-          <ac:inkMkLst>
-            <pc:docMk/>
-            <pc:sldMk cId="4029029847" sldId="297"/>
-            <ac:inkMk id="18" creationId="{4C907A66-EF7D-E74C-87DC-5A8F99A25ACE}"/>
-          </ac:inkMkLst>
-        </pc:inkChg>
-        <pc:inkChg chg="add mod">
-          <ac:chgData name="Marcos Maillot" userId="fa14b39d-e966-4ebb-a436-4f96f84b9577" providerId="ADAL" clId="{2D40D906-DE93-44E5-B192-09259B1B360B}" dt="2025-11-26T00:25:09.239" v="83"/>
-          <ac:inkMkLst>
-            <pc:docMk/>
-            <pc:sldMk cId="4029029847" sldId="297"/>
-            <ac:inkMk id="19" creationId="{4CE01419-A607-CB86-E658-8DCB2778F629}"/>
-          </ac:inkMkLst>
-        </pc:inkChg>
-        <pc:inkChg chg="add">
-          <ac:chgData name="Marcos Maillot" userId="fa14b39d-e966-4ebb-a436-4f96f84b9577" providerId="ADAL" clId="{2D40D906-DE93-44E5-B192-09259B1B360B}" dt="2025-11-26T00:25:10.036" v="84" actId="9405"/>
-          <ac:inkMkLst>
-            <pc:docMk/>
-            <pc:sldMk cId="4029029847" sldId="297"/>
-            <ac:inkMk id="21" creationId="{DF7F2824-55B0-7D68-F89F-21FDBA20F4BC}"/>
-          </ac:inkMkLst>
-        </pc:inkChg>
-        <pc:inkChg chg="add mod">
-          <ac:chgData name="Marcos Maillot" userId="fa14b39d-e966-4ebb-a436-4f96f84b9577" providerId="ADAL" clId="{2D40D906-DE93-44E5-B192-09259B1B360B}" dt="2025-11-26T00:28:35.766" v="167"/>
-          <ac:inkMkLst>
-            <pc:docMk/>
-            <pc:sldMk cId="4029029847" sldId="297"/>
-            <ac:inkMk id="22" creationId="{F7C53D33-3BFA-4762-188D-B6D18C7FF277}"/>
-          </ac:inkMkLst>
-        </pc:inkChg>
-        <pc:inkChg chg="add mod">
-          <ac:chgData name="Marcos Maillot" userId="fa14b39d-e966-4ebb-a436-4f96f84b9577" providerId="ADAL" clId="{2D40D906-DE93-44E5-B192-09259B1B360B}" dt="2025-11-26T00:25:22.931" v="100"/>
-          <ac:inkMkLst>
-            <pc:docMk/>
-            <pc:sldMk cId="4029029847" sldId="297"/>
-            <ac:inkMk id="24" creationId="{FB182551-99FA-89F3-4C40-1870CA8944B0}"/>
-          </ac:inkMkLst>
-        </pc:inkChg>
-        <pc:inkChg chg="add mod">
-          <ac:chgData name="Marcos Maillot" userId="fa14b39d-e966-4ebb-a436-4f96f84b9577" providerId="ADAL" clId="{2D40D906-DE93-44E5-B192-09259B1B360B}" dt="2025-11-26T00:25:22.931" v="100"/>
-          <ac:inkMkLst>
-            <pc:docMk/>
-            <pc:sldMk cId="4029029847" sldId="297"/>
-            <ac:inkMk id="25" creationId="{02320052-02DF-88E0-BA86-5A9522B83CEA}"/>
-          </ac:inkMkLst>
-        </pc:inkChg>
-        <pc:inkChg chg="add mod">
-          <ac:chgData name="Marcos Maillot" userId="fa14b39d-e966-4ebb-a436-4f96f84b9577" providerId="ADAL" clId="{2D40D906-DE93-44E5-B192-09259B1B360B}" dt="2025-11-26T00:25:14.736" v="93"/>
-          <ac:inkMkLst>
-            <pc:docMk/>
-            <pc:sldMk cId="4029029847" sldId="297"/>
-            <ac:inkMk id="26" creationId="{281670FA-5523-C0D9-A808-57AAE7CFB59C}"/>
-          </ac:inkMkLst>
-        </pc:inkChg>
-        <pc:inkChg chg="add mod">
-          <ac:chgData name="Marcos Maillot" userId="fa14b39d-e966-4ebb-a436-4f96f84b9577" providerId="ADAL" clId="{2D40D906-DE93-44E5-B192-09259B1B360B}" dt="2025-11-26T00:25:14.736" v="93"/>
-          <ac:inkMkLst>
-            <pc:docMk/>
-            <pc:sldMk cId="4029029847" sldId="297"/>
-            <ac:inkMk id="27" creationId="{E745D484-52FF-2778-C732-5BAD43704E9A}"/>
-          </ac:inkMkLst>
-        </pc:inkChg>
-        <pc:inkChg chg="add mod">
-          <ac:chgData name="Marcos Maillot" userId="fa14b39d-e966-4ebb-a436-4f96f84b9577" providerId="ADAL" clId="{2D40D906-DE93-44E5-B192-09259B1B360B}" dt="2025-11-26T00:28:32.254" v="163"/>
-          <ac:inkMkLst>
-            <pc:docMk/>
-            <pc:sldMk cId="4029029847" sldId="297"/>
-            <ac:inkMk id="28" creationId="{DE00FA5C-376A-B81B-423F-2B8F3DA60C59}"/>
-          </ac:inkMkLst>
-        </pc:inkChg>
-        <pc:inkChg chg="add mod">
-          <ac:chgData name="Marcos Maillot" userId="fa14b39d-e966-4ebb-a436-4f96f84b9577" providerId="ADAL" clId="{2D40D906-DE93-44E5-B192-09259B1B360B}" dt="2025-11-26T00:28:32.254" v="163"/>
-          <ac:inkMkLst>
-            <pc:docMk/>
-            <pc:sldMk cId="4029029847" sldId="297"/>
-            <ac:inkMk id="29" creationId="{1F04C6CE-E848-A4B8-A93F-8534BF9D849B}"/>
-          </ac:inkMkLst>
-        </pc:inkChg>
-        <pc:inkChg chg="add mod">
-          <ac:chgData name="Marcos Maillot" userId="fa14b39d-e966-4ebb-a436-4f96f84b9577" providerId="ADAL" clId="{2D40D906-DE93-44E5-B192-09259B1B360B}" dt="2025-11-26T00:28:35.766" v="167"/>
-          <ac:inkMkLst>
-            <pc:docMk/>
-            <pc:sldMk cId="4029029847" sldId="297"/>
-            <ac:inkMk id="32" creationId="{0CF302E0-E6E6-98DD-5247-191234670637}"/>
-          </ac:inkMkLst>
-        </pc:inkChg>
-        <pc:inkChg chg="add mod">
-          <ac:chgData name="Marcos Maillot" userId="fa14b39d-e966-4ebb-a436-4f96f84b9577" providerId="ADAL" clId="{2D40D906-DE93-44E5-B192-09259B1B360B}" dt="2025-11-26T00:25:22.931" v="100"/>
-          <ac:inkMkLst>
-            <pc:docMk/>
-            <pc:sldMk cId="4029029847" sldId="297"/>
-            <ac:inkMk id="33" creationId="{2E05C220-D7DB-05FC-446F-B898B16BFED8}"/>
-          </ac:inkMkLst>
-        </pc:inkChg>
-        <pc:inkChg chg="add">
-          <ac:chgData name="Marcos Maillot" userId="fa14b39d-e966-4ebb-a436-4f96f84b9577" providerId="ADAL" clId="{2D40D906-DE93-44E5-B192-09259B1B360B}" dt="2025-11-26T00:25:20.251" v="96" actId="9405"/>
-          <ac:inkMkLst>
-            <pc:docMk/>
-            <pc:sldMk cId="4029029847" sldId="297"/>
-            <ac:inkMk id="34" creationId="{364D06F4-5DF0-6CA8-13A3-83328B02A449}"/>
-          </ac:inkMkLst>
-        </pc:inkChg>
-        <pc:inkChg chg="add mod">
-          <ac:chgData name="Marcos Maillot" userId="fa14b39d-e966-4ebb-a436-4f96f84b9577" providerId="ADAL" clId="{2D40D906-DE93-44E5-B192-09259B1B360B}" dt="2025-11-26T00:28:32.254" v="163"/>
-          <ac:inkMkLst>
-            <pc:docMk/>
-            <pc:sldMk cId="4029029847" sldId="297"/>
-            <ac:inkMk id="35" creationId="{7B402CA4-D6E5-D7C0-9230-FF0CD54C31ED}"/>
-          </ac:inkMkLst>
-        </pc:inkChg>
-        <pc:inkChg chg="add mod">
-          <ac:chgData name="Marcos Maillot" userId="fa14b39d-e966-4ebb-a436-4f96f84b9577" providerId="ADAL" clId="{2D40D906-DE93-44E5-B192-09259B1B360B}" dt="2025-11-26T00:28:32.254" v="163"/>
-          <ac:inkMkLst>
-            <pc:docMk/>
-            <pc:sldMk cId="4029029847" sldId="297"/>
-            <ac:inkMk id="36" creationId="{BCB41DBC-53F6-2EF0-B995-A490655FF264}"/>
-          </ac:inkMkLst>
-        </pc:inkChg>
-        <pc:inkChg chg="add mod">
-          <ac:chgData name="Marcos Maillot" userId="fa14b39d-e966-4ebb-a436-4f96f84b9577" providerId="ADAL" clId="{2D40D906-DE93-44E5-B192-09259B1B360B}" dt="2025-11-26T00:25:53.788" v="148"/>
-          <ac:inkMkLst>
-            <pc:docMk/>
-            <pc:sldMk cId="4029029847" sldId="297"/>
-            <ac:inkMk id="37" creationId="{839437BA-87D5-9CDC-64F0-B58C3FB2B1FD}"/>
-          </ac:inkMkLst>
-        </pc:inkChg>
-        <pc:inkChg chg="add">
-          <ac:chgData name="Marcos Maillot" userId="fa14b39d-e966-4ebb-a436-4f96f84b9577" providerId="ADAL" clId="{2D40D906-DE93-44E5-B192-09259B1B360B}" dt="2025-11-26T00:25:24.064" v="101" actId="9405"/>
-          <ac:inkMkLst>
-            <pc:docMk/>
-            <pc:sldMk cId="4029029847" sldId="297"/>
-            <ac:inkMk id="40" creationId="{679D4FBA-BF4A-CE32-BFAB-AB362FC0B9E3}"/>
-          </ac:inkMkLst>
-        </pc:inkChg>
-        <pc:inkChg chg="add mod">
-          <ac:chgData name="Marcos Maillot" userId="fa14b39d-e966-4ebb-a436-4f96f84b9577" providerId="ADAL" clId="{2D40D906-DE93-44E5-B192-09259B1B360B}" dt="2025-11-26T00:25:31.805" v="117"/>
-          <ac:inkMkLst>
-            <pc:docMk/>
-            <pc:sldMk cId="4029029847" sldId="297"/>
-            <ac:inkMk id="41" creationId="{066BFE7C-E322-42D5-530B-50728ADD1BF1}"/>
-          </ac:inkMkLst>
-        </pc:inkChg>
-        <pc:inkChg chg="add">
-          <ac:chgData name="Marcos Maillot" userId="fa14b39d-e966-4ebb-a436-4f96f84b9577" providerId="ADAL" clId="{2D40D906-DE93-44E5-B192-09259B1B360B}" dt="2025-11-26T00:25:25.054" v="103" actId="9405"/>
-          <ac:inkMkLst>
-            <pc:docMk/>
-            <pc:sldMk cId="4029029847" sldId="297"/>
-            <ac:inkMk id="42" creationId="{F99C5AB3-0DA2-2473-AF6B-AEB7FA7F938F}"/>
-          </ac:inkMkLst>
-        </pc:inkChg>
-        <pc:inkChg chg="add mod">
-          <ac:chgData name="Marcos Maillot" userId="fa14b39d-e966-4ebb-a436-4f96f84b9577" providerId="ADAL" clId="{2D40D906-DE93-44E5-B192-09259B1B360B}" dt="2025-11-26T00:25:31.805" v="117"/>
-          <ac:inkMkLst>
-            <pc:docMk/>
-            <pc:sldMk cId="4029029847" sldId="297"/>
-            <ac:inkMk id="43" creationId="{22FAB2B7-2F01-BA77-374A-79575AD0A9D3}"/>
-          </ac:inkMkLst>
-        </pc:inkChg>
-        <pc:inkChg chg="add mod">
-          <ac:chgData name="Marcos Maillot" userId="fa14b39d-e966-4ebb-a436-4f96f84b9577" providerId="ADAL" clId="{2D40D906-DE93-44E5-B192-09259B1B360B}" dt="2025-11-26T00:25:31.805" v="117"/>
-          <ac:inkMkLst>
-            <pc:docMk/>
-            <pc:sldMk cId="4029029847" sldId="297"/>
-            <ac:inkMk id="44" creationId="{70980A64-E48B-585F-31D2-ED213C85B0CF}"/>
-          </ac:inkMkLst>
-        </pc:inkChg>
-        <pc:inkChg chg="add">
-          <ac:chgData name="Marcos Maillot" userId="fa14b39d-e966-4ebb-a436-4f96f84b9577" providerId="ADAL" clId="{2D40D906-DE93-44E5-B192-09259B1B360B}" dt="2025-11-26T00:25:25.926" v="106" actId="9405"/>
-          <ac:inkMkLst>
-            <pc:docMk/>
-            <pc:sldMk cId="4029029847" sldId="297"/>
-            <ac:inkMk id="45" creationId="{04B49CFC-18E9-17EF-1375-B2FDDDC893CC}"/>
-          </ac:inkMkLst>
-        </pc:inkChg>
-        <pc:inkChg chg="add">
-          <ac:chgData name="Marcos Maillot" userId="fa14b39d-e966-4ebb-a436-4f96f84b9577" providerId="ADAL" clId="{2D40D906-DE93-44E5-B192-09259B1B360B}" dt="2025-11-26T00:25:26.327" v="107" actId="9405"/>
-          <ac:inkMkLst>
-            <pc:docMk/>
-            <pc:sldMk cId="4029029847" sldId="297"/>
-            <ac:inkMk id="46" creationId="{07B30524-0440-22B6-8DC2-EBFB3914573A}"/>
-          </ac:inkMkLst>
-        </pc:inkChg>
-        <pc:inkChg chg="add mod">
-          <ac:chgData name="Marcos Maillot" userId="fa14b39d-e966-4ebb-a436-4f96f84b9577" providerId="ADAL" clId="{2D40D906-DE93-44E5-B192-09259B1B360B}" dt="2025-11-26T00:25:31.805" v="117"/>
-          <ac:inkMkLst>
-            <pc:docMk/>
-            <pc:sldMk cId="4029029847" sldId="297"/>
-            <ac:inkMk id="47" creationId="{F959F874-D508-9A06-29B4-D9CAACCC0743}"/>
-          </ac:inkMkLst>
-        </pc:inkChg>
-        <pc:inkChg chg="add">
-          <ac:chgData name="Marcos Maillot" userId="fa14b39d-e966-4ebb-a436-4f96f84b9577" providerId="ADAL" clId="{2D40D906-DE93-44E5-B192-09259B1B360B}" dt="2025-11-26T00:25:27.002" v="109" actId="9405"/>
-          <ac:inkMkLst>
-            <pc:docMk/>
-            <pc:sldMk cId="4029029847" sldId="297"/>
-            <ac:inkMk id="48" creationId="{402953DD-069F-D023-DF91-1AF1260A08A9}"/>
-          </ac:inkMkLst>
-        </pc:inkChg>
-        <pc:inkChg chg="add mod">
-          <ac:chgData name="Marcos Maillot" userId="fa14b39d-e966-4ebb-a436-4f96f84b9577" providerId="ADAL" clId="{2D40D906-DE93-44E5-B192-09259B1B360B}" dt="2025-11-26T00:25:58.792" v="153"/>
-          <ac:inkMkLst>
-            <pc:docMk/>
-            <pc:sldMk cId="4029029847" sldId="297"/>
-            <ac:inkMk id="49" creationId="{D95CCF6E-3BBD-E149-BAB3-B7C75E8D3135}"/>
-          </ac:inkMkLst>
-        </pc:inkChg>
-        <pc:inkChg chg="add">
-          <ac:chgData name="Marcos Maillot" userId="fa14b39d-e966-4ebb-a436-4f96f84b9577" providerId="ADAL" clId="{2D40D906-DE93-44E5-B192-09259B1B360B}" dt="2025-11-26T00:25:29.014" v="111" actId="9405"/>
-          <ac:inkMkLst>
-            <pc:docMk/>
-            <pc:sldMk cId="4029029847" sldId="297"/>
-            <ac:inkMk id="50" creationId="{18376188-0CC4-A6C6-2B34-5C0C57B8C4B4}"/>
-          </ac:inkMkLst>
-        </pc:inkChg>
-        <pc:inkChg chg="add">
-          <ac:chgData name="Marcos Maillot" userId="fa14b39d-e966-4ebb-a436-4f96f84b9577" providerId="ADAL" clId="{2D40D906-DE93-44E5-B192-09259B1B360B}" dt="2025-11-26T00:25:29.382" v="112" actId="9405"/>
-          <ac:inkMkLst>
-            <pc:docMk/>
-            <pc:sldMk cId="4029029847" sldId="297"/>
-            <ac:inkMk id="51" creationId="{1B17B2D6-A1C9-19A5-58AA-A7C9F1F5706D}"/>
-          </ac:inkMkLst>
-        </pc:inkChg>
-        <pc:inkChg chg="add">
-          <ac:chgData name="Marcos Maillot" userId="fa14b39d-e966-4ebb-a436-4f96f84b9577" providerId="ADAL" clId="{2D40D906-DE93-44E5-B192-09259B1B360B}" dt="2025-11-26T00:25:29.810" v="113" actId="9405"/>
-          <ac:inkMkLst>
-            <pc:docMk/>
-            <pc:sldMk cId="4029029847" sldId="297"/>
-            <ac:inkMk id="52" creationId="{B02893D7-5D36-9A20-62C3-35F0EEA78DCA}"/>
-          </ac:inkMkLst>
-        </pc:inkChg>
-        <pc:inkChg chg="add">
-          <ac:chgData name="Marcos Maillot" userId="fa14b39d-e966-4ebb-a436-4f96f84b9577" providerId="ADAL" clId="{2D40D906-DE93-44E5-B192-09259B1B360B}" dt="2025-11-26T00:25:30.177" v="114" actId="9405"/>
-          <ac:inkMkLst>
-            <pc:docMk/>
-            <pc:sldMk cId="4029029847" sldId="297"/>
-            <ac:inkMk id="53" creationId="{D74563C1-F32B-9E45-A3BD-06FEF0AFC1A5}"/>
-          </ac:inkMkLst>
-        </pc:inkChg>
-        <pc:inkChg chg="add">
-          <ac:chgData name="Marcos Maillot" userId="fa14b39d-e966-4ebb-a436-4f96f84b9577" providerId="ADAL" clId="{2D40D906-DE93-44E5-B192-09259B1B360B}" dt="2025-11-26T00:25:30.644" v="115" actId="9405"/>
-          <ac:inkMkLst>
-            <pc:docMk/>
-            <pc:sldMk cId="4029029847" sldId="297"/>
-            <ac:inkMk id="54" creationId="{53A84B3F-8F69-9B08-547F-97786FD08BDE}"/>
-          </ac:inkMkLst>
-        </pc:inkChg>
-        <pc:inkChg chg="add mod">
-          <ac:chgData name="Marcos Maillot" userId="fa14b39d-e966-4ebb-a436-4f96f84b9577" providerId="ADAL" clId="{2D40D906-DE93-44E5-B192-09259B1B360B}" dt="2025-11-26T00:25:31.805" v="117"/>
-          <ac:inkMkLst>
-            <pc:docMk/>
-            <pc:sldMk cId="4029029847" sldId="297"/>
-            <ac:inkMk id="55" creationId="{B0B058D2-9004-C29E-E5F9-2B820964F4F2}"/>
-          </ac:inkMkLst>
-        </pc:inkChg>
-        <pc:inkChg chg="add mod">
-          <ac:chgData name="Marcos Maillot" userId="fa14b39d-e966-4ebb-a436-4f96f84b9577" providerId="ADAL" clId="{2D40D906-DE93-44E5-B192-09259B1B360B}" dt="2025-11-26T00:25:36.931" v="123"/>
-          <ac:inkMkLst>
-            <pc:docMk/>
-            <pc:sldMk cId="4029029847" sldId="297"/>
-            <ac:inkMk id="60" creationId="{86A91B98-D4B7-59F7-881A-B3367DEDBCED}"/>
-          </ac:inkMkLst>
-        </pc:inkChg>
-        <pc:inkChg chg="add mod">
-          <ac:chgData name="Marcos Maillot" userId="fa14b39d-e966-4ebb-a436-4f96f84b9577" providerId="ADAL" clId="{2D40D906-DE93-44E5-B192-09259B1B360B}" dt="2025-11-26T00:25:36.931" v="123"/>
-          <ac:inkMkLst>
-            <pc:docMk/>
-            <pc:sldMk cId="4029029847" sldId="297"/>
-            <ac:inkMk id="61" creationId="{441297E7-D8BF-9C1A-B38D-A3AE4CEC634E}"/>
-          </ac:inkMkLst>
-        </pc:inkChg>
-        <pc:inkChg chg="add mod">
-          <ac:chgData name="Marcos Maillot" userId="fa14b39d-e966-4ebb-a436-4f96f84b9577" providerId="ADAL" clId="{2D40D906-DE93-44E5-B192-09259B1B360B}" dt="2025-11-26T00:25:58.792" v="153"/>
-          <ac:inkMkLst>
-            <pc:docMk/>
-            <pc:sldMk cId="4029029847" sldId="297"/>
-            <ac:inkMk id="62" creationId="{C79E816A-F6AD-E3FF-ABAC-384194B710A1}"/>
-          </ac:inkMkLst>
-        </pc:inkChg>
-        <pc:inkChg chg="add mod">
-          <ac:chgData name="Marcos Maillot" userId="fa14b39d-e966-4ebb-a436-4f96f84b9577" providerId="ADAL" clId="{2D40D906-DE93-44E5-B192-09259B1B360B}" dt="2025-11-26T00:25:58.792" v="153"/>
-          <ac:inkMkLst>
-            <pc:docMk/>
-            <pc:sldMk cId="4029029847" sldId="297"/>
-            <ac:inkMk id="63" creationId="{670E44A8-8979-BFFF-B652-38B1D69CFF14}"/>
-          </ac:inkMkLst>
-        </pc:inkChg>
-        <pc:inkChg chg="add mod">
-          <ac:chgData name="Marcos Maillot" userId="fa14b39d-e966-4ebb-a436-4f96f84b9577" providerId="ADAL" clId="{2D40D906-DE93-44E5-B192-09259B1B360B}" dt="2025-11-26T00:25:36.931" v="123"/>
-          <ac:inkMkLst>
-            <pc:docMk/>
-            <pc:sldMk cId="4029029847" sldId="297"/>
-            <ac:inkMk id="64" creationId="{F11A53C7-FFB0-A627-8A57-583363EE8412}"/>
-          </ac:inkMkLst>
-        </pc:inkChg>
-        <pc:inkChg chg="add mod">
-          <ac:chgData name="Marcos Maillot" userId="fa14b39d-e966-4ebb-a436-4f96f84b9577" providerId="ADAL" clId="{2D40D906-DE93-44E5-B192-09259B1B360B}" dt="2025-11-26T00:25:46.786" v="133"/>
-          <ac:inkMkLst>
-            <pc:docMk/>
-            <pc:sldMk cId="4029029847" sldId="297"/>
-            <ac:inkMk id="67" creationId="{EF2792D2-2544-CE23-34A9-07B63EDD8908}"/>
-          </ac:inkMkLst>
-        </pc:inkChg>
-        <pc:inkChg chg="add mod">
-          <ac:chgData name="Marcos Maillot" userId="fa14b39d-e966-4ebb-a436-4f96f84b9577" providerId="ADAL" clId="{2D40D906-DE93-44E5-B192-09259B1B360B}" dt="2025-11-26T00:25:46.786" v="133"/>
-          <ac:inkMkLst>
-            <pc:docMk/>
-            <pc:sldMk cId="4029029847" sldId="297"/>
-            <ac:inkMk id="68" creationId="{003EF94B-162C-AC51-0EDD-35AA8229AD7F}"/>
-          </ac:inkMkLst>
-        </pc:inkChg>
-        <pc:inkChg chg="add mod">
-          <ac:chgData name="Marcos Maillot" userId="fa14b39d-e966-4ebb-a436-4f96f84b9577" providerId="ADAL" clId="{2D40D906-DE93-44E5-B192-09259B1B360B}" dt="2025-11-26T00:25:46.786" v="133"/>
-          <ac:inkMkLst>
-            <pc:docMk/>
-            <pc:sldMk cId="4029029847" sldId="297"/>
-            <ac:inkMk id="69" creationId="{374A03BD-FB56-2D53-171E-343C57A6255B}"/>
-          </ac:inkMkLst>
-        </pc:inkChg>
-        <pc:inkChg chg="add mod">
-          <ac:chgData name="Marcos Maillot" userId="fa14b39d-e966-4ebb-a436-4f96f84b9577" providerId="ADAL" clId="{2D40D906-DE93-44E5-B192-09259B1B360B}" dt="2025-11-26T00:25:46.786" v="133"/>
-          <ac:inkMkLst>
-            <pc:docMk/>
-            <pc:sldMk cId="4029029847" sldId="297"/>
-            <ac:inkMk id="70" creationId="{D719FF61-34D7-5136-2C68-B3598E195CF8}"/>
-          </ac:inkMkLst>
-        </pc:inkChg>
-        <pc:inkChg chg="add mod">
-          <ac:chgData name="Marcos Maillot" userId="fa14b39d-e966-4ebb-a436-4f96f84b9577" providerId="ADAL" clId="{2D40D906-DE93-44E5-B192-09259B1B360B}" dt="2025-11-26T00:25:46.786" v="133"/>
-          <ac:inkMkLst>
-            <pc:docMk/>
-            <pc:sldMk cId="4029029847" sldId="297"/>
-            <ac:inkMk id="71" creationId="{74F4EF1A-1DE8-3758-CCEC-4953444E9693}"/>
-          </ac:inkMkLst>
-        </pc:inkChg>
-        <pc:inkChg chg="add mod">
-          <ac:chgData name="Marcos Maillot" userId="fa14b39d-e966-4ebb-a436-4f96f84b9577" providerId="ADAL" clId="{2D40D906-DE93-44E5-B192-09259B1B360B}" dt="2025-11-26T00:25:46.786" v="133"/>
-          <ac:inkMkLst>
-            <pc:docMk/>
-            <pc:sldMk cId="4029029847" sldId="297"/>
-            <ac:inkMk id="72" creationId="{54CBFE8A-93B2-DDE9-2591-ED891E873BE0}"/>
-          </ac:inkMkLst>
-        </pc:inkChg>
-        <pc:inkChg chg="add mod">
-          <ac:chgData name="Marcos Maillot" userId="fa14b39d-e966-4ebb-a436-4f96f84b9577" providerId="ADAL" clId="{2D40D906-DE93-44E5-B192-09259B1B360B}" dt="2025-11-26T00:25:46.786" v="133"/>
-          <ac:inkMkLst>
-            <pc:docMk/>
-            <pc:sldMk cId="4029029847" sldId="297"/>
-            <ac:inkMk id="73" creationId="{142FF88B-DCCE-01A1-9DDF-FD2A0E0B9B19}"/>
-          </ac:inkMkLst>
-        </pc:inkChg>
-        <pc:inkChg chg="add mod">
-          <ac:chgData name="Marcos Maillot" userId="fa14b39d-e966-4ebb-a436-4f96f84b9577" providerId="ADAL" clId="{2D40D906-DE93-44E5-B192-09259B1B360B}" dt="2025-11-26T00:25:46.786" v="133"/>
-          <ac:inkMkLst>
-            <pc:docMk/>
-            <pc:sldMk cId="4029029847" sldId="297"/>
-            <ac:inkMk id="74" creationId="{A2E89852-812E-CFBF-3501-41E4E3330D82}"/>
-          </ac:inkMkLst>
-        </pc:inkChg>
-        <pc:inkChg chg="add">
-          <ac:chgData name="Marcos Maillot" userId="fa14b39d-e966-4ebb-a436-4f96f84b9577" providerId="ADAL" clId="{2D40D906-DE93-44E5-B192-09259B1B360B}" dt="2025-11-26T00:25:46.124" v="132" actId="9405"/>
-          <ac:inkMkLst>
-            <pc:docMk/>
-            <pc:sldMk cId="4029029847" sldId="297"/>
-            <ac:inkMk id="75" creationId="{B41D8AF0-4982-AAB4-8BC2-D6E7569902D7}"/>
-          </ac:inkMkLst>
-        </pc:inkChg>
-        <pc:inkChg chg="add">
-          <ac:chgData name="Marcos Maillot" userId="fa14b39d-e966-4ebb-a436-4f96f84b9577" providerId="ADAL" clId="{2D40D906-DE93-44E5-B192-09259B1B360B}" dt="2025-11-26T00:25:47.820" v="134" actId="9405"/>
-          <ac:inkMkLst>
-            <pc:docMk/>
-            <pc:sldMk cId="4029029847" sldId="297"/>
-            <ac:inkMk id="77" creationId="{DBA2F192-1578-314A-7E80-21FEF1122F28}"/>
-          </ac:inkMkLst>
-        </pc:inkChg>
-        <pc:inkChg chg="add mod">
-          <ac:chgData name="Marcos Maillot" userId="fa14b39d-e966-4ebb-a436-4f96f84b9577" providerId="ADAL" clId="{2D40D906-DE93-44E5-B192-09259B1B360B}" dt="2025-11-26T00:25:52.369" v="146"/>
-          <ac:inkMkLst>
-            <pc:docMk/>
-            <pc:sldMk cId="4029029847" sldId="297"/>
-            <ac:inkMk id="78" creationId="{1E202CA1-80AF-FB2D-8CA0-BB2C33283F21}"/>
-          </ac:inkMkLst>
-        </pc:inkChg>
-        <pc:inkChg chg="add mod">
-          <ac:chgData name="Marcos Maillot" userId="fa14b39d-e966-4ebb-a436-4f96f84b9577" providerId="ADAL" clId="{2D40D906-DE93-44E5-B192-09259B1B360B}" dt="2025-11-26T00:25:52.369" v="146"/>
-          <ac:inkMkLst>
-            <pc:docMk/>
-            <pc:sldMk cId="4029029847" sldId="297"/>
-            <ac:inkMk id="79" creationId="{051BD74B-9878-84DA-E9A7-29709FB32E21}"/>
-          </ac:inkMkLst>
-        </pc:inkChg>
-        <pc:inkChg chg="add mod">
-          <ac:chgData name="Marcos Maillot" userId="fa14b39d-e966-4ebb-a436-4f96f84b9577" providerId="ADAL" clId="{2D40D906-DE93-44E5-B192-09259B1B360B}" dt="2025-11-26T00:25:52.369" v="146"/>
-          <ac:inkMkLst>
-            <pc:docMk/>
-            <pc:sldMk cId="4029029847" sldId="297"/>
-            <ac:inkMk id="80" creationId="{5CBE570B-03C5-3D60-2842-F475324CF942}"/>
-          </ac:inkMkLst>
-        </pc:inkChg>
-        <pc:inkChg chg="add mod">
-          <ac:chgData name="Marcos Maillot" userId="fa14b39d-e966-4ebb-a436-4f96f84b9577" providerId="ADAL" clId="{2D40D906-DE93-44E5-B192-09259B1B360B}" dt="2025-11-26T00:25:52.369" v="146"/>
-          <ac:inkMkLst>
-            <pc:docMk/>
-            <pc:sldMk cId="4029029847" sldId="297"/>
-            <ac:inkMk id="81" creationId="{7E63957A-976E-B143-1B2F-2D1CC5564CCB}"/>
-          </ac:inkMkLst>
-        </pc:inkChg>
-        <pc:inkChg chg="add">
-          <ac:chgData name="Marcos Maillot" userId="fa14b39d-e966-4ebb-a436-4f96f84b9577" providerId="ADAL" clId="{2D40D906-DE93-44E5-B192-09259B1B360B}" dt="2025-11-26T00:25:49.467" v="139" actId="9405"/>
-          <ac:inkMkLst>
-            <pc:docMk/>
-            <pc:sldMk cId="4029029847" sldId="297"/>
-            <ac:inkMk id="82" creationId="{5651D99B-E1EE-D818-9CF0-665976986099}"/>
-          </ac:inkMkLst>
-        </pc:inkChg>
-        <pc:inkChg chg="add mod">
-          <ac:chgData name="Marcos Maillot" userId="fa14b39d-e966-4ebb-a436-4f96f84b9577" providerId="ADAL" clId="{2D40D906-DE93-44E5-B192-09259B1B360B}" dt="2025-11-26T00:25:52.369" v="146"/>
-          <ac:inkMkLst>
-            <pc:docMk/>
-            <pc:sldMk cId="4029029847" sldId="297"/>
-            <ac:inkMk id="83" creationId="{C3FAC871-1474-CCC6-5E87-E2AC0D12EAE9}"/>
-          </ac:inkMkLst>
-        </pc:inkChg>
-        <pc:inkChg chg="add mod">
-          <ac:chgData name="Marcos Maillot" userId="fa14b39d-e966-4ebb-a436-4f96f84b9577" providerId="ADAL" clId="{2D40D906-DE93-44E5-B192-09259B1B360B}" dt="2025-11-26T00:25:52.369" v="146"/>
-          <ac:inkMkLst>
-            <pc:docMk/>
-            <pc:sldMk cId="4029029847" sldId="297"/>
-            <ac:inkMk id="84" creationId="{0E8A687A-DEA0-388D-FB86-CCBD0B729216}"/>
-          </ac:inkMkLst>
-        </pc:inkChg>
-        <pc:inkChg chg="add mod">
-          <ac:chgData name="Marcos Maillot" userId="fa14b39d-e966-4ebb-a436-4f96f84b9577" providerId="ADAL" clId="{2D40D906-DE93-44E5-B192-09259B1B360B}" dt="2025-11-26T00:25:52.369" v="146"/>
-          <ac:inkMkLst>
-            <pc:docMk/>
-            <pc:sldMk cId="4029029847" sldId="297"/>
-            <ac:inkMk id="85" creationId="{B43A0DFE-86F9-28BF-FE29-3526F9F5DBBF}"/>
-          </ac:inkMkLst>
-        </pc:inkChg>
-        <pc:inkChg chg="add mod">
-          <ac:chgData name="Marcos Maillot" userId="fa14b39d-e966-4ebb-a436-4f96f84b9577" providerId="ADAL" clId="{2D40D906-DE93-44E5-B192-09259B1B360B}" dt="2025-11-26T00:25:52.369" v="146"/>
-          <ac:inkMkLst>
-            <pc:docMk/>
-            <pc:sldMk cId="4029029847" sldId="297"/>
-            <ac:inkMk id="86" creationId="{B4F68EF2-D8B8-E613-D085-FC5C6E2C0002}"/>
-          </ac:inkMkLst>
-        </pc:inkChg>
-        <pc:inkChg chg="add mod">
-          <ac:chgData name="Marcos Maillot" userId="fa14b39d-e966-4ebb-a436-4f96f84b9577" providerId="ADAL" clId="{2D40D906-DE93-44E5-B192-09259B1B360B}" dt="2025-11-26T00:25:52.369" v="146"/>
-          <ac:inkMkLst>
-            <pc:docMk/>
-            <pc:sldMk cId="4029029847" sldId="297"/>
-            <ac:inkMk id="87" creationId="{25708BF6-4283-BA61-3448-0C2277C4BD0E}"/>
-          </ac:inkMkLst>
-        </pc:inkChg>
-        <pc:inkChg chg="add">
-          <ac:chgData name="Marcos Maillot" userId="fa14b39d-e966-4ebb-a436-4f96f84b9577" providerId="ADAL" clId="{2D40D906-DE93-44E5-B192-09259B1B360B}" dt="2025-11-26T00:25:51.375" v="145" actId="9405"/>
-          <ac:inkMkLst>
-            <pc:docMk/>
-            <pc:sldMk cId="4029029847" sldId="297"/>
-            <ac:inkMk id="88" creationId="{C7418F46-EF07-426A-AA4B-F220BFC0930F}"/>
-          </ac:inkMkLst>
-        </pc:inkChg>
-        <pc:inkChg chg="add mod">
-          <ac:chgData name="Marcos Maillot" userId="fa14b39d-e966-4ebb-a436-4f96f84b9577" providerId="ADAL" clId="{2D40D906-DE93-44E5-B192-09259B1B360B}" dt="2025-11-26T00:25:53.788" v="148"/>
-          <ac:inkMkLst>
-            <pc:docMk/>
-            <pc:sldMk cId="4029029847" sldId="297"/>
-            <ac:inkMk id="90" creationId="{70B3F775-FA51-6544-4803-4A10048D96A5}"/>
-          </ac:inkMkLst>
-        </pc:inkChg>
-        <pc:inkChg chg="add mod">
-          <ac:chgData name="Marcos Maillot" userId="fa14b39d-e966-4ebb-a436-4f96f84b9577" providerId="ADAL" clId="{2D40D906-DE93-44E5-B192-09259B1B360B}" dt="2025-11-26T00:25:58.792" v="153"/>
-          <ac:inkMkLst>
-            <pc:docMk/>
-            <pc:sldMk cId="4029029847" sldId="297"/>
-            <ac:inkMk id="92" creationId="{BDB7526B-2AEE-F10F-CC7F-FB57BEA2919F}"/>
-          </ac:inkMkLst>
-        </pc:inkChg>
-        <pc:inkChg chg="add">
-          <ac:chgData name="Marcos Maillot" userId="fa14b39d-e966-4ebb-a436-4f96f84b9577" providerId="ADAL" clId="{2D40D906-DE93-44E5-B192-09259B1B360B}" dt="2025-11-26T00:25:55.645" v="150" actId="9405"/>
-          <ac:inkMkLst>
-            <pc:docMk/>
-            <pc:sldMk cId="4029029847" sldId="297"/>
-            <ac:inkMk id="93" creationId="{083412AE-C9E2-355C-DFD5-3D11A458FA6F}"/>
-          </ac:inkMkLst>
-        </pc:inkChg>
-        <pc:inkChg chg="add">
-          <ac:chgData name="Marcos Maillot" userId="fa14b39d-e966-4ebb-a436-4f96f84b9577" providerId="ADAL" clId="{2D40D906-DE93-44E5-B192-09259B1B360B}" dt="2025-11-26T00:25:56.496" v="151" actId="9405"/>
-          <ac:inkMkLst>
-            <pc:docMk/>
-            <pc:sldMk cId="4029029847" sldId="297"/>
-            <ac:inkMk id="94" creationId="{EC266792-024C-703E-7D18-1FCC9D2D6834}"/>
-          </ac:inkMkLst>
-        </pc:inkChg>
-        <pc:inkChg chg="add">
-          <ac:chgData name="Marcos Maillot" userId="fa14b39d-e966-4ebb-a436-4f96f84b9577" providerId="ADAL" clId="{2D40D906-DE93-44E5-B192-09259B1B360B}" dt="2025-11-26T00:25:57.867" v="152" actId="9405"/>
-          <ac:inkMkLst>
-            <pc:docMk/>
-            <pc:sldMk cId="4029029847" sldId="297"/>
-            <ac:inkMk id="95" creationId="{7235CC50-8306-612F-A377-7D69D5854DA1}"/>
-          </ac:inkMkLst>
-        </pc:inkChg>
-        <pc:inkChg chg="add">
-          <ac:chgData name="Marcos Maillot" userId="fa14b39d-e966-4ebb-a436-4f96f84b9577" providerId="ADAL" clId="{2D40D906-DE93-44E5-B192-09259B1B360B}" dt="2025-11-26T00:26:05.026" v="154" actId="9405"/>
-          <ac:inkMkLst>
-            <pc:docMk/>
-            <pc:sldMk cId="4029029847" sldId="297"/>
-            <ac:inkMk id="99" creationId="{E911E237-C4D2-5370-2134-7D2055CFA37B}"/>
-          </ac:inkMkLst>
-        </pc:inkChg>
-        <pc:inkChg chg="add">
-          <ac:chgData name="Marcos Maillot" userId="fa14b39d-e966-4ebb-a436-4f96f84b9577" providerId="ADAL" clId="{2D40D906-DE93-44E5-B192-09259B1B360B}" dt="2025-11-26T00:28:24.726" v="157" actId="9405"/>
-          <ac:inkMkLst>
-            <pc:docMk/>
-            <pc:sldMk cId="4029029847" sldId="297"/>
-            <ac:inkMk id="100" creationId="{F36A5EEB-F939-D20D-6E34-9EB73F2FA80A}"/>
-          </ac:inkMkLst>
-        </pc:inkChg>
-        <pc:inkChg chg="add mod">
-          <ac:chgData name="Marcos Maillot" userId="fa14b39d-e966-4ebb-a436-4f96f84b9577" providerId="ADAL" clId="{2D40D906-DE93-44E5-B192-09259B1B360B}" dt="2025-11-26T00:28:35.766" v="167"/>
-          <ac:inkMkLst>
-            <pc:docMk/>
-            <pc:sldMk cId="4029029847" sldId="297"/>
-            <ac:inkMk id="101" creationId="{EC313D64-5AE9-F0D3-E1C3-9196C0E75301}"/>
-          </ac:inkMkLst>
-        </pc:inkChg>
-        <pc:inkChg chg="add mod">
-          <ac:chgData name="Marcos Maillot" userId="fa14b39d-e966-4ebb-a436-4f96f84b9577" providerId="ADAL" clId="{2D40D906-DE93-44E5-B192-09259B1B360B}" dt="2025-11-26T00:28:29.351" v="161"/>
-          <ac:inkMkLst>
-            <pc:docMk/>
-            <pc:sldMk cId="4029029847" sldId="297"/>
-            <ac:inkMk id="103" creationId="{D213921E-137D-2691-7EC4-70A6E1A4B04A}"/>
-          </ac:inkMkLst>
-        </pc:inkChg>
-        <pc:inkChg chg="add mod">
-          <ac:chgData name="Marcos Maillot" userId="fa14b39d-e966-4ebb-a436-4f96f84b9577" providerId="ADAL" clId="{2D40D906-DE93-44E5-B192-09259B1B360B}" dt="2025-11-26T00:28:35.766" v="167"/>
-          <ac:inkMkLst>
-            <pc:docMk/>
-            <pc:sldMk cId="4029029847" sldId="297"/>
-            <ac:inkMk id="105" creationId="{47B6BA57-879F-B0B9-90EC-3D50D08FBA1D}"/>
-          </ac:inkMkLst>
-        </pc:inkChg>
-        <pc:inkChg chg="add">
-          <ac:chgData name="Marcos Maillot" userId="fa14b39d-e966-4ebb-a436-4f96f84b9577" providerId="ADAL" clId="{2D40D906-DE93-44E5-B192-09259B1B360B}" dt="2025-11-26T00:28:32.856" v="164" actId="9405"/>
-          <ac:inkMkLst>
-            <pc:docMk/>
-            <pc:sldMk cId="4029029847" sldId="297"/>
-            <ac:inkMk id="107" creationId="{5EC29041-88CC-124A-D94C-47215D7AEBF5}"/>
-          </ac:inkMkLst>
-        </pc:inkChg>
-        <pc:inkChg chg="add">
-          <ac:chgData name="Marcos Maillot" userId="fa14b39d-e966-4ebb-a436-4f96f84b9577" providerId="ADAL" clId="{2D40D906-DE93-44E5-B192-09259B1B360B}" dt="2025-11-26T00:28:33.848" v="165" actId="9405"/>
-          <ac:inkMkLst>
-            <pc:docMk/>
-            <pc:sldMk cId="4029029847" sldId="297"/>
-            <ac:inkMk id="108" creationId="{D1F11B4B-AAB0-E2C8-BC84-8BCB9B6C33D7}"/>
-          </ac:inkMkLst>
-        </pc:inkChg>
-        <pc:inkChg chg="add">
-          <ac:chgData name="Marcos Maillot" userId="fa14b39d-e966-4ebb-a436-4f96f84b9577" providerId="ADAL" clId="{2D40D906-DE93-44E5-B192-09259B1B360B}" dt="2025-11-26T00:28:34.620" v="166" actId="9405"/>
-          <ac:inkMkLst>
-            <pc:docMk/>
-            <pc:sldMk cId="4029029847" sldId="297"/>
-            <ac:inkMk id="109" creationId="{CFF2CFE7-67D1-0155-DD2E-4C73F5738F84}"/>
-          </ac:inkMkLst>
-        </pc:inkChg>
-      </pc:sldChg>
-    </pc:docChg>
-  </pc:docChgLst>
-  <pc:docChgLst>
-    <pc:chgData name="Marcos Maillot" userId="fa14b39d-e966-4ebb-a436-4f96f84b9577" providerId="ADAL" clId="{99863556-EDB4-416E-A189-D7BEBC9D2890}"/>
-    <pc:docChg chg="custSel addSld modSld sldOrd">
-      <pc:chgData name="Marcos Maillot" userId="fa14b39d-e966-4ebb-a436-4f96f84b9577" providerId="ADAL" clId="{99863556-EDB4-416E-A189-D7BEBC9D2890}" dt="2025-04-08T20:00:51.115" v="134" actId="478"/>
+    <pc:chgData name="Marcos Maillot" userId="fa14b39d-e966-4ebb-a436-4f96f84b9577" providerId="ADAL" clId="{152A8D8E-FC9A-4326-9172-4A160D290924}"/>
+    <pc:docChg chg="modSld">
+      <pc:chgData name="Marcos Maillot" userId="fa14b39d-e966-4ebb-a436-4f96f84b9577" providerId="ADAL" clId="{152A8D8E-FC9A-4326-9172-4A160D290924}" dt="2026-04-08T00:27:12.203" v="1" actId="1076"/>
       <pc:docMkLst>
         <pc:docMk/>
       </pc:docMkLst>
       <pc:sldChg chg="modSp mod">
-        <pc:chgData name="Marcos Maillot" userId="fa14b39d-e966-4ebb-a436-4f96f84b9577" providerId="ADAL" clId="{99863556-EDB4-416E-A189-D7BEBC9D2890}" dt="2025-04-08T19:39:40.991" v="2" actId="20577"/>
+        <pc:chgData name="Marcos Maillot" userId="fa14b39d-e966-4ebb-a436-4f96f84b9577" providerId="ADAL" clId="{152A8D8E-FC9A-4326-9172-4A160D290924}" dt="2026-04-07T19:00:54.713" v="0" actId="14100"/>
         <pc:sldMkLst>
           <pc:docMk/>
-          <pc:sldMk cId="0" sldId="256"/>
+          <pc:sldMk cId="0" sldId="276"/>
         </pc:sldMkLst>
+        <pc:spChg chg="mod">
+          <ac:chgData name="Marcos Maillot" userId="fa14b39d-e966-4ebb-a436-4f96f84b9577" providerId="ADAL" clId="{152A8D8E-FC9A-4326-9172-4A160D290924}" dt="2026-04-07T19:00:54.713" v="0" actId="14100"/>
+          <ac:spMkLst>
+            <pc:docMk/>
+            <pc:sldMk cId="0" sldId="276"/>
+            <ac:spMk id="270" creationId="{00000000-0000-0000-0000-000000000000}"/>
+          </ac:spMkLst>
+        </pc:spChg>
       </pc:sldChg>
       <pc:sldChg chg="modSp mod">
-        <pc:chgData name="Marcos Maillot" userId="fa14b39d-e966-4ebb-a436-4f96f84b9577" providerId="ADAL" clId="{99863556-EDB4-416E-A189-D7BEBC9D2890}" dt="2025-04-08T19:41:13.160" v="75" actId="20577"/>
-        <pc:sldMkLst>
-          <pc:docMk/>
-          <pc:sldMk cId="0" sldId="257"/>
-        </pc:sldMkLst>
-      </pc:sldChg>
-      <pc:sldChg chg="addSp delSp mod">
-        <pc:chgData name="Marcos Maillot" userId="fa14b39d-e966-4ebb-a436-4f96f84b9577" providerId="ADAL" clId="{99863556-EDB4-416E-A189-D7BEBC9D2890}" dt="2025-04-08T19:48:44.570" v="80" actId="478"/>
-        <pc:sldMkLst>
-          <pc:docMk/>
-          <pc:sldMk cId="0" sldId="272"/>
-        </pc:sldMkLst>
-      </pc:sldChg>
-      <pc:sldChg chg="ord modNotes">
-        <pc:chgData name="Marcos Maillot" userId="fa14b39d-e966-4ebb-a436-4f96f84b9577" providerId="ADAL" clId="{99863556-EDB4-416E-A189-D7BEBC9D2890}" dt="2025-04-08T19:42:14.891" v="77"/>
-        <pc:sldMkLst>
-          <pc:docMk/>
-          <pc:sldMk cId="0" sldId="274"/>
-        </pc:sldMkLst>
-      </pc:sldChg>
-      <pc:sldChg chg="addSp delSp modSp add mod">
-        <pc:chgData name="Marcos Maillot" userId="fa14b39d-e966-4ebb-a436-4f96f84b9577" providerId="ADAL" clId="{99863556-EDB4-416E-A189-D7BEBC9D2890}" dt="2025-04-08T20:00:43.352" v="133" actId="14100"/>
-        <pc:sldMkLst>
-          <pc:docMk/>
-          <pc:sldMk cId="3064181911" sldId="295"/>
-        </pc:sldMkLst>
-      </pc:sldChg>
-      <pc:sldChg chg="addSp delSp modSp add mod">
-        <pc:chgData name="Marcos Maillot" userId="fa14b39d-e966-4ebb-a436-4f96f84b9577" providerId="ADAL" clId="{99863556-EDB4-416E-A189-D7BEBC9D2890}" dt="2025-04-08T20:00:51.115" v="134" actId="478"/>
-        <pc:sldMkLst>
-          <pc:docMk/>
-          <pc:sldMk cId="238751435" sldId="296"/>
-        </pc:sldMkLst>
-      </pc:sldChg>
-    </pc:docChg>
-  </pc:docChgLst>
-  <pc:docChgLst>
-    <pc:chgData name="Marcos Maillot" userId="fa14b39d-e966-4ebb-a436-4f96f84b9577" providerId="ADAL" clId="{76C5211C-8193-4505-88DA-CC4F89F88FF3}"/>
-    <pc:docChg chg="undo custSel addSld modSld">
-      <pc:chgData name="Marcos Maillot" userId="fa14b39d-e966-4ebb-a436-4f96f84b9577" providerId="ADAL" clId="{76C5211C-8193-4505-88DA-CC4F89F88FF3}" dt="2025-10-08T22:56:21.209" v="101" actId="478"/>
-      <pc:docMkLst>
-        <pc:docMk/>
-      </pc:docMkLst>
-      <pc:sldChg chg="delSp mod">
-        <pc:chgData name="Marcos Maillot" userId="fa14b39d-e966-4ebb-a436-4f96f84b9577" providerId="ADAL" clId="{76C5211C-8193-4505-88DA-CC4F89F88FF3}" dt="2025-10-08T22:56:21.209" v="101" actId="478"/>
-        <pc:sldMkLst>
-          <pc:docMk/>
-          <pc:sldMk cId="0" sldId="285"/>
-        </pc:sldMkLst>
-      </pc:sldChg>
-      <pc:sldChg chg="addSp delSp mod">
-        <pc:chgData name="Marcos Maillot" userId="fa14b39d-e966-4ebb-a436-4f96f84b9577" providerId="ADAL" clId="{76C5211C-8193-4505-88DA-CC4F89F88FF3}" dt="2025-10-08T22:18:51.610" v="100" actId="478"/>
-        <pc:sldMkLst>
-          <pc:docMk/>
-          <pc:sldMk cId="2515468531" sldId="290"/>
-        </pc:sldMkLst>
-      </pc:sldChg>
-      <pc:sldChg chg="addSp delSp modSp new mod">
-        <pc:chgData name="Marcos Maillot" userId="fa14b39d-e966-4ebb-a436-4f96f84b9577" providerId="ADAL" clId="{76C5211C-8193-4505-88DA-CC4F89F88FF3}" dt="2025-10-08T00:04:44.038" v="88"/>
-        <pc:sldMkLst>
-          <pc:docMk/>
-          <pc:sldMk cId="3552047750" sldId="297"/>
-        </pc:sldMkLst>
-      </pc:sldChg>
-    </pc:docChg>
-  </pc:docChgLst>
-  <pc:docChgLst>
-    <pc:chgData name="Marcos Maillot" userId="fa14b39d-e966-4ebb-a436-4f96f84b9577" providerId="ADAL" clId="{7C9B03B3-4DBB-48A5-996A-D234D8E380B0}"/>
-    <pc:docChg chg="custSel modSld">
-      <pc:chgData name="Marcos Maillot" userId="fa14b39d-e966-4ebb-a436-4f96f84b9577" providerId="ADAL" clId="{7C9B03B3-4DBB-48A5-996A-D234D8E380B0}" dt="2025-06-04T00:41:13.996" v="53"/>
-      <pc:docMkLst>
-        <pc:docMk/>
-      </pc:docMkLst>
-      <pc:sldChg chg="modSp mod">
-        <pc:chgData name="Marcos Maillot" userId="fa14b39d-e966-4ebb-a436-4f96f84b9577" providerId="ADAL" clId="{7C9B03B3-4DBB-48A5-996A-D234D8E380B0}" dt="2025-06-03T14:24:31.393" v="36" actId="20577"/>
-        <pc:sldMkLst>
-          <pc:docMk/>
-          <pc:sldMk cId="0" sldId="257"/>
-        </pc:sldMkLst>
-      </pc:sldChg>
-      <pc:sldChg chg="addSp delSp modSp mod">
-        <pc:chgData name="Marcos Maillot" userId="fa14b39d-e966-4ebb-a436-4f96f84b9577" providerId="ADAL" clId="{7C9B03B3-4DBB-48A5-996A-D234D8E380B0}" dt="2025-06-04T00:41:13.996" v="53"/>
-        <pc:sldMkLst>
-          <pc:docMk/>
-          <pc:sldMk cId="2515468531" sldId="290"/>
-        </pc:sldMkLst>
-      </pc:sldChg>
-    </pc:docChg>
-  </pc:docChgLst>
-  <pc:docChgLst>
-    <pc:chgData name="Marcos Maillot" userId="fa14b39d-e966-4ebb-a436-4f96f84b9577" providerId="ADAL" clId="{8ACB5DE9-95AA-4FA1-BB62-A7FBF6739BEF}"/>
-    <pc:docChg chg="custSel modSld">
-      <pc:chgData name="Marcos Maillot" userId="fa14b39d-e966-4ebb-a436-4f96f84b9577" providerId="ADAL" clId="{8ACB5DE9-95AA-4FA1-BB62-A7FBF6739BEF}" dt="2024-08-03T00:55:09.122" v="28" actId="14100"/>
-      <pc:docMkLst>
-        <pc:docMk/>
-      </pc:docMkLst>
-      <pc:sldChg chg="modSp mod">
-        <pc:chgData name="Marcos Maillot" userId="fa14b39d-e966-4ebb-a436-4f96f84b9577" providerId="ADAL" clId="{8ACB5DE9-95AA-4FA1-BB62-A7FBF6739BEF}" dt="2024-08-02T21:05:36.646" v="10" actId="20577"/>
-        <pc:sldMkLst>
-          <pc:docMk/>
-          <pc:sldMk cId="0" sldId="256"/>
-        </pc:sldMkLst>
-      </pc:sldChg>
-      <pc:sldChg chg="modSp mod">
-        <pc:chgData name="Marcos Maillot" userId="fa14b39d-e966-4ebb-a436-4f96f84b9577" providerId="ADAL" clId="{8ACB5DE9-95AA-4FA1-BB62-A7FBF6739BEF}" dt="2024-08-02T21:06:30.023" v="23" actId="14100"/>
+        <pc:chgData name="Marcos Maillot" userId="fa14b39d-e966-4ebb-a436-4f96f84b9577" providerId="ADAL" clId="{152A8D8E-FC9A-4326-9172-4A160D290924}" dt="2026-04-08T00:27:12.203" v="1" actId="1076"/>
         <pc:sldMkLst>
           <pc:docMk/>
           <pc:sldMk cId="0" sldId="277"/>
         </pc:sldMkLst>
-      </pc:sldChg>
-      <pc:sldChg chg="addSp delSp modSp mod">
-        <pc:chgData name="Marcos Maillot" userId="fa14b39d-e966-4ebb-a436-4f96f84b9577" providerId="ADAL" clId="{8ACB5DE9-95AA-4FA1-BB62-A7FBF6739BEF}" dt="2024-08-03T00:55:09.122" v="28" actId="14100"/>
-        <pc:sldMkLst>
-          <pc:docMk/>
-          <pc:sldMk cId="0" sldId="289"/>
-        </pc:sldMkLst>
-      </pc:sldChg>
-    </pc:docChg>
-  </pc:docChgLst>
-  <pc:docChgLst>
-    <pc:chgData name="Marcos Maillot" userId="fa14b39d-e966-4ebb-a436-4f96f84b9577" providerId="ADAL" clId="{EE2FC811-F246-4E28-936B-C5BA500BDF68}"/>
-    <pc:docChg chg="undo custSel addSld modSld sldOrd">
-      <pc:chgData name="Marcos Maillot" userId="fa14b39d-e966-4ebb-a436-4f96f84b9577" providerId="ADAL" clId="{EE2FC811-F246-4E28-936B-C5BA500BDF68}" dt="2024-10-01T23:23:19.274" v="36"/>
-      <pc:docMkLst>
-        <pc:docMk/>
-      </pc:docMkLst>
-      <pc:sldChg chg="modSp mod">
-        <pc:chgData name="Marcos Maillot" userId="fa14b39d-e966-4ebb-a436-4f96f84b9577" providerId="ADAL" clId="{EE2FC811-F246-4E28-936B-C5BA500BDF68}" dt="2024-10-01T16:27:37.771" v="3" actId="14100"/>
-        <pc:sldMkLst>
-          <pc:docMk/>
-          <pc:sldMk cId="0" sldId="263"/>
-        </pc:sldMkLst>
-      </pc:sldChg>
-      <pc:sldChg chg="modSp mod">
-        <pc:chgData name="Marcos Maillot" userId="fa14b39d-e966-4ebb-a436-4f96f84b9577" providerId="ADAL" clId="{EE2FC811-F246-4E28-936B-C5BA500BDF68}" dt="2024-10-01T16:28:12.091" v="11" actId="5793"/>
-        <pc:sldMkLst>
-          <pc:docMk/>
-          <pc:sldMk cId="0" sldId="272"/>
-        </pc:sldMkLst>
-      </pc:sldChg>
-      <pc:sldChg chg="modSp mod">
-        <pc:chgData name="Marcos Maillot" userId="fa14b39d-e966-4ebb-a436-4f96f84b9577" providerId="ADAL" clId="{EE2FC811-F246-4E28-936B-C5BA500BDF68}" dt="2024-10-01T23:22:22.814" v="15" actId="27636"/>
-        <pc:sldMkLst>
-          <pc:docMk/>
-          <pc:sldMk cId="0" sldId="273"/>
-        </pc:sldMkLst>
-      </pc:sldChg>
-      <pc:sldChg chg="ord">
-        <pc:chgData name="Marcos Maillot" userId="fa14b39d-e966-4ebb-a436-4f96f84b9577" providerId="ADAL" clId="{EE2FC811-F246-4E28-936B-C5BA500BDF68}" dt="2024-10-01T23:21:50.675" v="13"/>
-        <pc:sldMkLst>
-          <pc:docMk/>
-          <pc:sldMk cId="0" sldId="279"/>
-        </pc:sldMkLst>
-      </pc:sldChg>
-      <pc:sldChg chg="addSp delSp modSp add mod">
-        <pc:chgData name="Marcos Maillot" userId="fa14b39d-e966-4ebb-a436-4f96f84b9577" providerId="ADAL" clId="{EE2FC811-F246-4E28-936B-C5BA500BDF68}" dt="2024-10-01T23:23:19.274" v="36"/>
-        <pc:sldMkLst>
-          <pc:docMk/>
-          <pc:sldMk cId="2515468531" sldId="290"/>
-        </pc:sldMkLst>
-      </pc:sldChg>
-    </pc:docChg>
-  </pc:docChgLst>
-  <pc:docChgLst>
-    <pc:chgData name="Marcos Maillot" userId="fa14b39d-e966-4ebb-a436-4f96f84b9577" providerId="ADAL" clId="{1E84885A-7552-472D-840C-9CF2BF35DFDB}"/>
-    <pc:docChg chg="custSel modSld">
-      <pc:chgData name="Marcos Maillot" userId="fa14b39d-e966-4ebb-a436-4f96f84b9577" providerId="ADAL" clId="{1E84885A-7552-472D-840C-9CF2BF35DFDB}" dt="2025-08-06T01:07:04.230" v="99"/>
-      <pc:docMkLst>
-        <pc:docMk/>
-      </pc:docMkLst>
-      <pc:sldChg chg="addSp delSp modSp mod">
-        <pc:chgData name="Marcos Maillot" userId="fa14b39d-e966-4ebb-a436-4f96f84b9577" providerId="ADAL" clId="{1E84885A-7552-472D-840C-9CF2BF35DFDB}" dt="2025-08-06T01:07:04.230" v="99"/>
-        <pc:sldMkLst>
-          <pc:docMk/>
-          <pc:sldMk cId="0" sldId="285"/>
-        </pc:sldMkLst>
-      </pc:sldChg>
-      <pc:sldChg chg="addSp delSp modSp mod">
-        <pc:chgData name="Marcos Maillot" userId="fa14b39d-e966-4ebb-a436-4f96f84b9577" providerId="ADAL" clId="{1E84885A-7552-472D-840C-9CF2BF35DFDB}" dt="2025-08-06T01:05:25.432" v="84"/>
-        <pc:sldMkLst>
-          <pc:docMk/>
-          <pc:sldMk cId="2515468531" sldId="290"/>
-        </pc:sldMkLst>
-      </pc:sldChg>
-    </pc:docChg>
-  </pc:docChgLst>
-  <pc:docChgLst>
-    <pc:chgData name="Marcos Maillot" userId="fa14b39d-e966-4ebb-a436-4f96f84b9577" providerId="ADAL" clId="{6875A249-7888-4363-9F92-056EB10F7CD5}"/>
-    <pc:docChg chg="custSel addSld modSld">
-      <pc:chgData name="Marcos Maillot" userId="fa14b39d-e966-4ebb-a436-4f96f84b9577" providerId="ADAL" clId="{6875A249-7888-4363-9F92-056EB10F7CD5}" dt="2024-11-29T21:45:30.394" v="57" actId="14100"/>
-      <pc:docMkLst>
-        <pc:docMk/>
-      </pc:docMkLst>
-      <pc:sldChg chg="modSp mod">
-        <pc:chgData name="Marcos Maillot" userId="fa14b39d-e966-4ebb-a436-4f96f84b9577" providerId="ADAL" clId="{6875A249-7888-4363-9F92-056EB10F7CD5}" dt="2024-11-29T21:45:30.394" v="57" actId="14100"/>
-        <pc:sldMkLst>
-          <pc:docMk/>
-          <pc:sldMk cId="0" sldId="278"/>
-        </pc:sldMkLst>
-      </pc:sldChg>
-      <pc:sldChg chg="addSp delSp modSp add mod">
-        <pc:chgData name="Marcos Maillot" userId="fa14b39d-e966-4ebb-a436-4f96f84b9577" providerId="ADAL" clId="{6875A249-7888-4363-9F92-056EB10F7CD5}" dt="2024-11-29T21:34:44.944" v="9" actId="1076"/>
-        <pc:sldMkLst>
-          <pc:docMk/>
-          <pc:sldMk cId="3137623413" sldId="291"/>
-        </pc:sldMkLst>
-      </pc:sldChg>
-      <pc:sldChg chg="addSp modSp add mod">
-        <pc:chgData name="Marcos Maillot" userId="fa14b39d-e966-4ebb-a436-4f96f84b9577" providerId="ADAL" clId="{6875A249-7888-4363-9F92-056EB10F7CD5}" dt="2024-11-29T21:36:07.654" v="22" actId="1076"/>
-        <pc:sldMkLst>
-          <pc:docMk/>
-          <pc:sldMk cId="4139229005" sldId="292"/>
-        </pc:sldMkLst>
-      </pc:sldChg>
-      <pc:sldChg chg="addSp delSp modSp add mod">
-        <pc:chgData name="Marcos Maillot" userId="fa14b39d-e966-4ebb-a436-4f96f84b9577" providerId="ADAL" clId="{6875A249-7888-4363-9F92-056EB10F7CD5}" dt="2024-11-29T21:37:21.674" v="39" actId="1076"/>
-        <pc:sldMkLst>
-          <pc:docMk/>
-          <pc:sldMk cId="3179616302" sldId="293"/>
-        </pc:sldMkLst>
-      </pc:sldChg>
-      <pc:sldChg chg="addSp delSp modSp add mod">
-        <pc:chgData name="Marcos Maillot" userId="fa14b39d-e966-4ebb-a436-4f96f84b9577" providerId="ADAL" clId="{6875A249-7888-4363-9F92-056EB10F7CD5}" dt="2024-11-29T21:39:33.364" v="55" actId="1076"/>
-        <pc:sldMkLst>
-          <pc:docMk/>
-          <pc:sldMk cId="1421602177" sldId="294"/>
-        </pc:sldMkLst>
+        <pc:picChg chg="mod">
+          <ac:chgData name="Marcos Maillot" userId="fa14b39d-e966-4ebb-a436-4f96f84b9577" providerId="ADAL" clId="{152A8D8E-FC9A-4326-9172-4A160D290924}" dt="2026-04-08T00:27:12.203" v="1" actId="1076"/>
+          <ac:picMkLst>
+            <pc:docMk/>
+            <pc:sldMk cId="0" sldId="277"/>
+            <ac:picMk id="276" creationId="{00000000-0000-0000-0000-000000000000}"/>
+          </ac:picMkLst>
+        </pc:picChg>
       </pc:sldChg>
     </pc:docChg>
   </pc:docChgLst>
@@ -5429,8 +3350,8 @@
         </p:nvSpPr>
         <p:spPr>
           <a:xfrm>
-            <a:off x="1143225" y="685800"/>
-            <a:ext cx="4572225" cy="3429000"/>
+            <a:off x="381000" y="685800"/>
+            <a:ext cx="6096000" cy="3429000"/>
           </a:xfrm>
           <a:custGeom>
             <a:avLst/>
@@ -8342,7 +6263,7 @@
             </a:pPr>
             <a:fld id="{00000000-1234-1234-1234-123412341234}" type="slidenum">
               <a:rPr lang="en"/>
-              <a:t>‹Nº›</a:t>
+              <a:t>‹#›</a:t>
             </a:fld>
             <a:endParaRPr/>
           </a:p>
@@ -9041,7 +6962,7 @@
             </a:pPr>
             <a:fld id="{00000000-1234-1234-1234-123412341234}" type="slidenum">
               <a:rPr lang="en"/>
-              <a:t>‹Nº›</a:t>
+              <a:t>‹#›</a:t>
             </a:fld>
             <a:endParaRPr/>
           </a:p>
@@ -9355,7 +7276,7 @@
             </a:pPr>
             <a:fld id="{00000000-1234-1234-1234-123412341234}" type="slidenum">
               <a:rPr lang="en"/>
-              <a:t>‹Nº›</a:t>
+              <a:t>‹#›</a:t>
             </a:fld>
             <a:endParaRPr/>
           </a:p>
@@ -10082,7 +8003,7 @@
             </a:pPr>
             <a:fld id="{00000000-1234-1234-1234-123412341234}" type="slidenum">
               <a:rPr lang="en"/>
-              <a:t>‹Nº›</a:t>
+              <a:t>‹#›</a:t>
             </a:fld>
             <a:endParaRPr/>
           </a:p>
@@ -10834,7 +8755,7 @@
             </a:pPr>
             <a:fld id="{00000000-1234-1234-1234-123412341234}" type="slidenum">
               <a:rPr lang="en"/>
-              <a:t>‹Nº›</a:t>
+              <a:t>‹#›</a:t>
             </a:fld>
             <a:endParaRPr/>
           </a:p>
@@ -11426,7 +9347,7 @@
             </a:pPr>
             <a:fld id="{00000000-1234-1234-1234-123412341234}" type="slidenum">
               <a:rPr lang="en"/>
-              <a:t>‹Nº›</a:t>
+              <a:t>‹#›</a:t>
             </a:fld>
             <a:endParaRPr/>
           </a:p>
@@ -11892,7 +9813,7 @@
             </a:pPr>
             <a:fld id="{00000000-1234-1234-1234-123412341234}" type="slidenum">
               <a:rPr lang="en"/>
-              <a:t>‹Nº›</a:t>
+              <a:t>‹#›</a:t>
             </a:fld>
             <a:endParaRPr/>
           </a:p>
@@ -12804,7 +10725,7 @@
             </a:pPr>
             <a:fld id="{00000000-1234-1234-1234-123412341234}" type="slidenum">
               <a:rPr lang="en"/>
-              <a:t>‹Nº›</a:t>
+              <a:t>‹#›</a:t>
             </a:fld>
             <a:endParaRPr/>
           </a:p>
@@ -13619,7 +11540,7 @@
             </a:pPr>
             <a:fld id="{00000000-1234-1234-1234-123412341234}" type="slidenum">
               <a:rPr lang="en"/>
-              <a:t>‹Nº›</a:t>
+              <a:t>‹#›</a:t>
             </a:fld>
             <a:endParaRPr/>
           </a:p>
@@ -14085,7 +12006,7 @@
             </a:pPr>
             <a:fld id="{00000000-1234-1234-1234-123412341234}" type="slidenum">
               <a:rPr lang="en"/>
-              <a:t>‹Nº›</a:t>
+              <a:t>‹#›</a:t>
             </a:fld>
             <a:endParaRPr/>
           </a:p>
@@ -15123,7 +13044,7 @@
             </a:pPr>
             <a:fld id="{00000000-1234-1234-1234-123412341234}" type="slidenum">
               <a:rPr lang="en"/>
-              <a:t>‹Nº›</a:t>
+              <a:t>‹#›</a:t>
             </a:fld>
             <a:endParaRPr/>
           </a:p>
@@ -15610,7 +13531,7 @@
             </a:pPr>
             <a:fld id="{00000000-1234-1234-1234-123412341234}" type="slidenum">
               <a:rPr lang="en"/>
-              <a:t>‹Nº›</a:t>
+              <a:t>‹#›</a:t>
             </a:fld>
             <a:endParaRPr/>
           </a:p>
@@ -16460,7 +14381,7 @@
             </a:pPr>
             <a:fld id="{00000000-1234-1234-1234-123412341234}" type="slidenum">
               <a:rPr lang="en"/>
-              <a:t>‹Nº›</a:t>
+              <a:t>‹#›</a:t>
             </a:fld>
             <a:endParaRPr/>
           </a:p>
@@ -19373,10 +17294,10 @@
                         <a:buNone/>
                       </a:pPr>
                       <a:r>
-                        <a:rPr lang="en" sz="1400"/>
+                        <a:rPr lang="en" sz="1400" dirty="0"/>
                         <a:t>Wih</a:t>
                       </a:r>
-                      <a:endParaRPr sz="1400"/>
+                      <a:endParaRPr sz="1400" dirty="0"/>
                     </a:p>
                   </a:txBody>
                   <a:tcPr marL="68600" marR="68600" marT="34300" marB="34300"/>
@@ -19464,10 +17385,10 @@
                         <a:buNone/>
                       </a:pPr>
                       <a:r>
-                        <a:rPr lang="en" sz="1400"/>
+                        <a:rPr lang="en" sz="1400" dirty="0"/>
                         <a:t>Bih</a:t>
                       </a:r>
-                      <a:endParaRPr sz="1400"/>
+                      <a:endParaRPr sz="1400" dirty="0"/>
                     </a:p>
                   </a:txBody>
                   <a:tcPr marL="68600" marR="68600" marT="34300" marB="34300"/>
@@ -19551,10 +17472,10 @@
                         <a:buNone/>
                       </a:pPr>
                       <a:r>
-                        <a:rPr lang="en" sz="1400"/>
+                        <a:rPr lang="en" sz="1400" dirty="0"/>
                         <a:t>Whh</a:t>
                       </a:r>
-                      <a:endParaRPr sz="1400"/>
+                      <a:endParaRPr sz="1400" dirty="0"/>
                     </a:p>
                   </a:txBody>
                   <a:tcPr marL="68600" marR="68600" marT="34300" marB="34300"/>
@@ -19638,10 +17559,10 @@
                         <a:buNone/>
                       </a:pPr>
                       <a:r>
-                        <a:rPr lang="en" sz="1400"/>
+                        <a:rPr lang="en" sz="1400" dirty="0"/>
                         <a:t>bhh</a:t>
                       </a:r>
-                      <a:endParaRPr sz="1400"/>
+                      <a:endParaRPr sz="1400" dirty="0"/>
                     </a:p>
                   </a:txBody>
                   <a:tcPr marL="68600" marR="68600" marT="34300" marB="34300"/>
@@ -19668,7 +17589,7 @@
                         <a:buFont typeface="Twentieth Century"/>
                         <a:buNone/>
                       </a:pPr>
-                      <a:endParaRPr sz="1400"/>
+                      <a:endParaRPr sz="1400" dirty="0"/>
                     </a:p>
                   </a:txBody>
                   <a:tcPr marL="68600" marR="68600" marT="34300" marB="34300"/>
@@ -27838,7 +25759,7 @@
         <p:spPr>
           <a:xfrm>
             <a:off x="3097280" y="3726450"/>
-            <a:ext cx="1215900" cy="300000"/>
+            <a:ext cx="1573872" cy="300000"/>
           </a:xfrm>
           <a:prstGeom prst="rect">
             <a:avLst/>
@@ -27864,7 +25785,7 @@
               <a:buNone/>
             </a:pPr>
             <a:r>
-              <a:rPr lang="en" sz="1800">
+              <a:rPr lang="en" sz="1800" dirty="0">
                 <a:solidFill>
                   <a:srgbClr val="FF0000"/>
                 </a:solidFill>
@@ -27875,7 +25796,7 @@
               </a:rPr>
               <a:t>Unfolded!!!!</a:t>
             </a:r>
-            <a:endParaRPr/>
+            <a:endParaRPr dirty="0"/>
           </a:p>
         </p:txBody>
       </p:sp>
@@ -28348,7 +26269,7 @@
         </p:blipFill>
         <p:spPr>
           <a:xfrm>
-            <a:off x="3646955" y="1112010"/>
+            <a:off x="3740620" y="1112010"/>
             <a:ext cx="5345718" cy="1838402"/>
           </a:xfrm>
           <a:prstGeom prst="rect">

</xml_diff>